<commit_message>
Flandre etendue jusque Hardelot/Boulonnais (lng 1.50-3.05): 65 sites, 9.1 ME/an
</commit_message>
<xml_diff>
--- a/fusion_flandre_codir.pptx
+++ b/fusion_flandre_codir.pptx
@@ -3404,7 +3404,7 @@
                 </a:solidFill>
                 <a:latin typeface="Calibri"/>
               </a:rPr>
-              <a:t>54</a:t>
+              <a:t>65</a:t>
             </a:r>
           </a:p>
         </p:txBody>
@@ -3474,7 +3474,7 @@
                 </a:solidFill>
                 <a:latin typeface="Calibri"/>
               </a:rPr>
-              <a:t>20</a:t>
+              <a:t>22</a:t>
             </a:r>
           </a:p>
         </p:txBody>
@@ -3544,7 +3544,7 @@
                 </a:solidFill>
                 <a:latin typeface="Calibri"/>
               </a:rPr>
-              <a:t>8.2 M€/an</a:t>
+              <a:t>9.1 M€/an</a:t>
             </a:r>
           </a:p>
         </p:txBody>
@@ -3702,7 +3702,7 @@
                 </a:solidFill>
                 <a:latin typeface="Calibri"/>
               </a:rPr>
-              <a:t>76 %</a:t>
+              <a:t>73 %</a:t>
             </a:r>
             <a:r>
               <a:rPr sz="1300" b="0">
@@ -4047,7 +4047,7 @@
                 </a:solidFill>
                 <a:latin typeface="Calibri"/>
               </a:rPr>
-              <a:t>4.7 M€</a:t>
+              <a:t>5.2 M€</a:t>
             </a:r>
           </a:p>
         </p:txBody>
@@ -4117,7 +4117,7 @@
                 </a:solidFill>
                 <a:latin typeface="Calibri"/>
               </a:rPr>
-              <a:t>• Charges fixes :  4 000 k€</a:t>
+              <a:t>• Charges fixes :  4 400 k€</a:t>
             </a:r>
           </a:p>
           <a:p>
@@ -4129,7 +4129,7 @@
                 </a:solidFill>
                 <a:latin typeface="Calibri"/>
               </a:rPr>
-              <a:t>• Pers. saisonnier :  400 k€</a:t>
+              <a:t>• Pers. saisonnier :  440 k€</a:t>
             </a:r>
           </a:p>
           <a:p>
@@ -4141,7 +4141,7 @@
                 </a:solidFill>
                 <a:latin typeface="Calibri"/>
               </a:rPr>
-              <a:t>• Capex évité :  200 k€</a:t>
+              <a:t>• Capex évité :  220 k€</a:t>
             </a:r>
           </a:p>
           <a:p>
@@ -4153,7 +4153,7 @@
                 </a:solidFill>
                 <a:latin typeface="Calibri"/>
               </a:rPr>
-              <a:t>• Optim. logistique :  105 k€</a:t>
+              <a:t>• Optim. logistique :  137 k€</a:t>
             </a:r>
           </a:p>
           <a:p>
@@ -4177,7 +4177,7 @@
                 </a:solidFill>
                 <a:latin typeface="Calibri"/>
               </a:rPr>
-              <a:t>Sur 20 sites fermés</a:t>
+              <a:t>Sur 22 sites fermés</a:t>
             </a:r>
           </a:p>
           <a:p>
@@ -4189,7 +4189,7 @@
                 </a:solidFill>
                 <a:latin typeface="Calibri"/>
               </a:rPr>
-              <a:t>52 310 t redéployées</a:t>
+              <a:t>68 573 t redéployées</a:t>
             </a:r>
           </a:p>
         </p:txBody>
@@ -4384,7 +4384,7 @@
                 </a:solidFill>
                 <a:latin typeface="Calibri"/>
               </a:rPr>
-              <a:t>8.2 M€</a:t>
+              <a:t>9.1 M€</a:t>
             </a:r>
           </a:p>
         </p:txBody>
@@ -4454,7 +4454,7 @@
                 </a:solidFill>
                 <a:latin typeface="Calibri"/>
               </a:rPr>
-              <a:t>• Charges fixes :  7 000 k€</a:t>
+              <a:t>• Charges fixes :  7 700 k€</a:t>
             </a:r>
           </a:p>
           <a:p>
@@ -4466,7 +4466,7 @@
                 </a:solidFill>
                 <a:latin typeface="Calibri"/>
               </a:rPr>
-              <a:t>• Pers. saisonnier :  600 k€</a:t>
+              <a:t>• Pers. saisonnier :  660 k€</a:t>
             </a:r>
           </a:p>
           <a:p>
@@ -4478,7 +4478,7 @@
                 </a:solidFill>
                 <a:latin typeface="Calibri"/>
               </a:rPr>
-              <a:t>• Capex évité :  400 k€</a:t>
+              <a:t>• Capex évité :  440 k€</a:t>
             </a:r>
           </a:p>
           <a:p>
@@ -4490,7 +4490,7 @@
                 </a:solidFill>
                 <a:latin typeface="Calibri"/>
               </a:rPr>
-              <a:t>• Optim. logistique :  209 k€</a:t>
+              <a:t>• Optim. logistique :  274 k€</a:t>
             </a:r>
           </a:p>
           <a:p>
@@ -4514,7 +4514,7 @@
                 </a:solidFill>
                 <a:latin typeface="Calibri"/>
               </a:rPr>
-              <a:t>Sur 20 sites fermés</a:t>
+              <a:t>Sur 22 sites fermés</a:t>
             </a:r>
           </a:p>
           <a:p>
@@ -4526,7 +4526,7 @@
                 </a:solidFill>
                 <a:latin typeface="Calibri"/>
               </a:rPr>
-              <a:t>52 310 t redéployées</a:t>
+              <a:t>68 573 t redéployées</a:t>
             </a:r>
           </a:p>
         </p:txBody>
@@ -4721,7 +4721,7 @@
                 </a:solidFill>
                 <a:latin typeface="Calibri"/>
               </a:rPr>
-              <a:t>11.7 M€</a:t>
+              <a:t>13.0 M€</a:t>
             </a:r>
           </a:p>
         </p:txBody>
@@ -4791,7 +4791,7 @@
                 </a:solidFill>
                 <a:latin typeface="Calibri"/>
               </a:rPr>
-              <a:t>• Charges fixes :  10 000 k€</a:t>
+              <a:t>• Charges fixes :  11 000 k€</a:t>
             </a:r>
           </a:p>
           <a:p>
@@ -4803,7 +4803,7 @@
                 </a:solidFill>
                 <a:latin typeface="Calibri"/>
               </a:rPr>
-              <a:t>• Pers. saisonnier :  800 k€</a:t>
+              <a:t>• Pers. saisonnier :  880 k€</a:t>
             </a:r>
           </a:p>
           <a:p>
@@ -4815,7 +4815,7 @@
                 </a:solidFill>
                 <a:latin typeface="Calibri"/>
               </a:rPr>
-              <a:t>• Capex évité :  600 k€</a:t>
+              <a:t>• Capex évité :  660 k€</a:t>
             </a:r>
           </a:p>
           <a:p>
@@ -4827,7 +4827,7 @@
                 </a:solidFill>
                 <a:latin typeface="Calibri"/>
               </a:rPr>
-              <a:t>• Optim. logistique :  314 k€</a:t>
+              <a:t>• Optim. logistique :  411 k€</a:t>
             </a:r>
           </a:p>
           <a:p>
@@ -4851,7 +4851,7 @@
                 </a:solidFill>
                 <a:latin typeface="Calibri"/>
               </a:rPr>
-              <a:t>Sur 20 sites fermés</a:t>
+              <a:t>Sur 22 sites fermés</a:t>
             </a:r>
           </a:p>
           <a:p>
@@ -4863,7 +4863,7 @@
                 </a:solidFill>
                 <a:latin typeface="Calibri"/>
               </a:rPr>
-              <a:t>52 310 t redéployées</a:t>
+              <a:t>68 573 t redéployées</a:t>
             </a:r>
           </a:p>
         </p:txBody>
@@ -6011,7 +6011,7 @@
                 </a:solidFill>
                 <a:latin typeface="Calibri"/>
               </a:rPr>
-              <a:t>1600 k€</a:t>
+              <a:t>1760 k€</a:t>
             </a:r>
           </a:p>
         </p:txBody>
@@ -6081,7 +6081,7 @@
                 </a:solidFill>
                 <a:latin typeface="Calibri"/>
               </a:rPr>
-              <a:t>2000–6000 k€</a:t>
+              <a:t>2200–6600 k€</a:t>
             </a:r>
           </a:p>
         </p:txBody>
@@ -7102,7 +7102,7 @@
                 </a:solidFill>
                 <a:latin typeface="Calibri"/>
               </a:rPr>
-              <a:t>11 sites</a:t>
+              <a:t>13 sites</a:t>
             </a:r>
           </a:p>
         </p:txBody>
@@ -7172,7 +7172,7 @@
                 </a:solidFill>
                 <a:latin typeface="Calibri"/>
               </a:rPr>
-              <a:t>30.8 kt</a:t>
+              <a:t>47.1 kt</a:t>
             </a:r>
           </a:p>
         </p:txBody>
@@ -7242,7 +7242,7 @@
                 </a:solidFill>
                 <a:latin typeface="Calibri"/>
               </a:rPr>
-              <a:t>30.8 kt (100.0%)</a:t>
+              <a:t>47.1 kt (100.0%)</a:t>
             </a:r>
           </a:p>
         </p:txBody>
@@ -7312,7 +7312,7 @@
                 </a:solidFill>
                 <a:latin typeface="Calibri"/>
               </a:rPr>
-              <a:t>+3 850 k€</a:t>
+              <a:t>+4 550 k€</a:t>
             </a:r>
           </a:p>
         </p:txBody>
@@ -7382,7 +7382,7 @@
                 </a:solidFill>
                 <a:latin typeface="Calibri"/>
               </a:rPr>
-              <a:t>-463 k€</a:t>
+              <a:t>-707 k€</a:t>
             </a:r>
           </a:p>
         </p:txBody>
@@ -7461,7 +7461,7 @@
                 </a:solidFill>
                 <a:latin typeface="Calibri"/>
               </a:rPr>
-              <a:t>NET : 3.39 M€/an</a:t>
+              <a:t>NET : 3.84 M€/an</a:t>
             </a:r>
           </a:p>
         </p:txBody>
@@ -7691,7 +7691,7 @@
                 </a:solidFill>
                 <a:latin typeface="Calibri"/>
               </a:rPr>
-              <a:t>20 sites</a:t>
+              <a:t>22 sites</a:t>
             </a:r>
           </a:p>
         </p:txBody>
@@ -7761,7 +7761,7 @@
                 </a:solidFill>
                 <a:latin typeface="Calibri"/>
               </a:rPr>
-              <a:t>52.3 kt</a:t>
+              <a:t>68.6 kt</a:t>
             </a:r>
           </a:p>
         </p:txBody>
@@ -7831,7 +7831,7 @@
                 </a:solidFill>
                 <a:latin typeface="Calibri"/>
               </a:rPr>
-              <a:t>51.4 kt (98.3%)</a:t>
+              <a:t>67.7 kt (98.7%)</a:t>
             </a:r>
           </a:p>
         </p:txBody>
@@ -7901,7 +7901,7 @@
                 </a:solidFill>
                 <a:latin typeface="Calibri"/>
               </a:rPr>
-              <a:t>+7 000 k€</a:t>
+              <a:t>+7 700 k€</a:t>
             </a:r>
           </a:p>
         </p:txBody>
@@ -7971,7 +7971,7 @@
                 </a:solidFill>
                 <a:latin typeface="Calibri"/>
               </a:rPr>
-              <a:t>-771 k€</a:t>
+              <a:t>-1 015 k€</a:t>
             </a:r>
           </a:p>
         </p:txBody>
@@ -8050,7 +8050,7 @@
                 </a:solidFill>
                 <a:latin typeface="Calibri"/>
               </a:rPr>
-              <a:t>NET : 6.23 M€/an</a:t>
+              <a:t>NET : 6.68 M€/an</a:t>
             </a:r>
           </a:p>
         </p:txBody>
@@ -8796,7 +8796,7 @@
                 </a:solidFill>
                 <a:latin typeface="Calibri"/>
               </a:rPr>
-              <a:t>Si pilote OK : 43 doublons identifiés sur les Hauts-de-France complets = potentiel total 18 M€/an (extrapolation).</a:t>
+              <a:t>Si pilote OK : 43 doublons identifiés sur les Hauts-de-France complets = potentiel total 20 M€/an (extrapolation).</a:t>
             </a:r>
           </a:p>
         </p:txBody>
@@ -9449,7 +9449,7 @@
                 </a:solidFill>
                 <a:latin typeface="Calibri"/>
               </a:rPr>
-              <a:t>•  lat 50.55-51.1 / lng 1.9-3.05  (rectangle géographique délimitant la Flandre)
+              <a:t>•  lat 50.55-51.1 / lng 1.5-3.05  (rectangle géographique délimitant la Flandre)
 •  Sud : ligne Saint-Omer / Béthune. Nord : frontière belge. Ouest : Boulonnais / Calais. Est : Lille / Armentières.
 •  Inclut : Flandre maritime (Dunkerque, Bergues, Hondschoote), Flandre intérieure (Cassel, Bailleul, Hazebrouck), Audomarois (St-Omer, Aire-sur-la-Lys), bordure Pas-de-Calais nord-est.</a:t>
             </a:r>
@@ -9646,7 +9646,7 @@
                 </a:solidFill>
                 <a:latin typeface="Calibri"/>
               </a:rPr>
-              <a:t>23</a:t>
+              <a:t>27</a:t>
             </a:r>
           </a:p>
         </p:txBody>
@@ -9681,7 +9681,7 @@
                 </a:solidFill>
                 <a:latin typeface="Calibri"/>
               </a:rPr>
-              <a:t>68.9 kt collectées R25</a:t>
+              <a:t>93.5 kt collectées R25</a:t>
             </a:r>
           </a:p>
         </p:txBody>
@@ -9876,7 +9876,7 @@
                 </a:solidFill>
                 <a:latin typeface="Calibri"/>
               </a:rPr>
-              <a:t>26</a:t>
+              <a:t>33</a:t>
             </a:r>
           </a:p>
         </p:txBody>
@@ -9911,7 +9911,7 @@
                 </a:solidFill>
                 <a:latin typeface="Calibri"/>
               </a:rPr>
-              <a:t>16 doublons Noriap &lt;7 km</a:t>
+              <a:t>18 doublons Noriap &lt;7 km</a:t>
             </a:r>
           </a:p>
         </p:txBody>
@@ -10396,7 +10396,7 @@
                 </a:solidFill>
                 <a:latin typeface="Calibri"/>
               </a:rPr>
-              <a:t>54</a:t>
+              <a:t>65</a:t>
             </a:r>
           </a:p>
         </p:txBody>
@@ -10431,7 +10431,7 @@
                 </a:solidFill>
                 <a:latin typeface="Calibri"/>
               </a:rPr>
-              <a:t>23 N • 26 U • 5 T</a:t>
+              <a:t>27 N • 33 U • 5 T</a:t>
             </a:r>
           </a:p>
         </p:txBody>
@@ -10589,7 +10589,7 @@
                 </a:solidFill>
                 <a:latin typeface="Calibri"/>
               </a:rPr>
-              <a:t>20</a:t>
+              <a:t>22</a:t>
             </a:r>
           </a:p>
         </p:txBody>
@@ -10624,7 +10624,7 @@
                 </a:solidFill>
                 <a:latin typeface="Calibri"/>
               </a:rPr>
-              <a:t>16 U • 7 T • 3 multi</a:t>
+              <a:t>18 U • 7 T • 3 multi</a:t>
             </a:r>
           </a:p>
         </p:txBody>
@@ -10782,7 +10782,7 @@
                 </a:solidFill>
                 <a:latin typeface="Calibri"/>
               </a:rPr>
-              <a:t>76%</a:t>
+              <a:t>73%</a:t>
             </a:r>
           </a:p>
         </p:txBody>
@@ -10817,7 +10817,7 @@
                 </a:solidFill>
                 <a:latin typeface="Calibri"/>
               </a:rPr>
-              <a:t>52 kt sur 69 kt</a:t>
+              <a:t>69 kt sur 93 kt</a:t>
             </a:r>
           </a:p>
         </p:txBody>
@@ -11589,7 +11589,7 @@
         <p:spPr>
           <a:xfrm>
             <a:off x="457200" y="1600200"/>
-            <a:ext cx="11277295" cy="566928"/>
+            <a:ext cx="11277295" cy="768096"/>
           </a:xfrm>
           <a:prstGeom prst="rect">
             <a:avLst/>
@@ -11633,7 +11633,7 @@
         <p:spPr>
           <a:xfrm>
             <a:off x="457200" y="1600200"/>
-            <a:ext cx="73152" cy="566928"/>
+            <a:ext cx="73152" cy="768096"/>
           </a:xfrm>
           <a:prstGeom prst="rect">
             <a:avLst/>
@@ -11677,7 +11677,7 @@
         <p:spPr>
           <a:xfrm>
             <a:off x="548640" y="1645920"/>
-            <a:ext cx="2651760" cy="566928"/>
+            <a:ext cx="2651760" cy="768096"/>
           </a:xfrm>
           <a:prstGeom prst="rect">
             <a:avLst/>
@@ -11698,7 +11698,7 @@
                 </a:solidFill>
                 <a:latin typeface="Calibri"/>
               </a:rPr>
-              <a:t>HOLQUE</a:t>
+              <a:t>MARQUISE</a:t>
             </a:r>
           </a:p>
         </p:txBody>
@@ -11712,7 +11712,7 @@
         <p:spPr>
           <a:xfrm>
             <a:off x="3200400" y="1645920"/>
-            <a:ext cx="1371600" cy="566928"/>
+            <a:ext cx="1371600" cy="768096"/>
           </a:xfrm>
           <a:prstGeom prst="rect">
             <a:avLst/>
@@ -11733,7 +11733,7 @@
                 </a:solidFill>
                 <a:latin typeface="Calibri"/>
               </a:rPr>
-              <a:t>6 870 t</a:t>
+              <a:t>11 050 t</a:t>
             </a:r>
           </a:p>
         </p:txBody>
@@ -11747,7 +11747,7 @@
         <p:spPr>
           <a:xfrm>
             <a:off x="4572000" y="1645920"/>
-            <a:ext cx="3383280" cy="566928"/>
+            <a:ext cx="3383280" cy="768096"/>
           </a:xfrm>
           <a:prstGeom prst="rect">
             <a:avLst/>
@@ -11768,7 +11768,7 @@
                 </a:solidFill>
                 <a:latin typeface="Calibri"/>
               </a:rPr>
-              <a:t>CAPPELLE-BROUCK (5.51 km)</a:t>
+              <a:t>MARQUISE (1.11 km)</a:t>
             </a:r>
           </a:p>
           <a:p>
@@ -11780,7 +11780,19 @@
                 </a:solidFill>
                 <a:latin typeface="Calibri"/>
               </a:rPr>
-              <a:t>LEDERZEELE (6.63 km)</a:t>
+              <a:t>RETY (5.96 km)</a:t>
+            </a:r>
+          </a:p>
+          <a:p>
+            <a:pPr algn="l"/>
+            <a:r>
+              <a:rPr sz="1000" b="0">
+                <a:solidFill>
+                  <a:srgbClr val="2CA02C"/>
+                </a:solidFill>
+                <a:latin typeface="Calibri"/>
+              </a:rPr>
+              <a:t>WIMILLE (6.55 km)</a:t>
             </a:r>
           </a:p>
         </p:txBody>
@@ -11794,7 +11806,7 @@
         <p:spPr>
           <a:xfrm>
             <a:off x="7955279" y="1645920"/>
-            <a:ext cx="3291840" cy="566928"/>
+            <a:ext cx="3291840" cy="768096"/>
           </a:xfrm>
           <a:prstGeom prst="rect">
             <a:avLst/>
@@ -11828,7 +11840,247 @@
         </p:nvSpPr>
         <p:spPr>
           <a:xfrm>
-            <a:off x="457200" y="2167128"/>
+            <a:off x="457200" y="2368296"/>
+            <a:ext cx="73152" cy="566928"/>
+          </a:xfrm>
+          <a:prstGeom prst="rect">
+            <a:avLst/>
+          </a:prstGeom>
+          <a:solidFill>
+            <a:srgbClr val="2CA02C"/>
+          </a:solidFill>
+          <a:ln>
+            <a:noFill/>
+          </a:ln>
+          <a:effectLst/>
+        </p:spPr>
+        <p:style>
+          <a:lnRef idx="1">
+            <a:schemeClr val="accent1"/>
+          </a:lnRef>
+          <a:fillRef idx="3">
+            <a:schemeClr val="accent1"/>
+          </a:fillRef>
+          <a:effectRef idx="2">
+            <a:schemeClr val="accent1"/>
+          </a:effectRef>
+          <a:fontRef idx="minor">
+            <a:schemeClr val="lt1"/>
+          </a:fontRef>
+        </p:style>
+        <p:txBody>
+          <a:bodyPr rtlCol="0" anchor="ctr"/>
+          <a:lstStyle/>
+          <a:p>
+            <a:pPr algn="ctr"/>
+          </a:p>
+        </p:txBody>
+      </p:sp>
+      <p:sp>
+        <p:nvSpPr>
+          <p:cNvPr id="17" name="TextBox 16"/>
+          <p:cNvSpPr txBox="1"/>
+          <p:nvPr/>
+        </p:nvSpPr>
+        <p:spPr>
+          <a:xfrm>
+            <a:off x="548640" y="2414016"/>
+            <a:ext cx="2651760" cy="566928"/>
+          </a:xfrm>
+          <a:prstGeom prst="rect">
+            <a:avLst/>
+          </a:prstGeom>
+          <a:noFill/>
+        </p:spPr>
+        <p:txBody>
+          <a:bodyPr wrap="square" lIns="45720" rIns="45720" anchor="t">
+            <a:spAutoFit/>
+          </a:bodyPr>
+          <a:lstStyle/>
+          <a:p>
+            <a:pPr algn="l"/>
+            <a:r>
+              <a:rPr sz="1200" b="1">
+                <a:solidFill>
+                  <a:srgbClr val="1A1A2E"/>
+                </a:solidFill>
+                <a:latin typeface="Calibri"/>
+              </a:rPr>
+              <a:t>HOLQUE</a:t>
+            </a:r>
+          </a:p>
+        </p:txBody>
+      </p:sp>
+      <p:sp>
+        <p:nvSpPr>
+          <p:cNvPr id="18" name="TextBox 17"/>
+          <p:cNvSpPr txBox="1"/>
+          <p:nvPr/>
+        </p:nvSpPr>
+        <p:spPr>
+          <a:xfrm>
+            <a:off x="3200400" y="2414016"/>
+            <a:ext cx="1371600" cy="566928"/>
+          </a:xfrm>
+          <a:prstGeom prst="rect">
+            <a:avLst/>
+          </a:prstGeom>
+          <a:noFill/>
+        </p:spPr>
+        <p:txBody>
+          <a:bodyPr wrap="square" lIns="45720" rIns="45720" anchor="t">
+            <a:spAutoFit/>
+          </a:bodyPr>
+          <a:lstStyle/>
+          <a:p>
+            <a:pPr algn="l"/>
+            <a:r>
+              <a:rPr sz="1200" b="0">
+                <a:solidFill>
+                  <a:srgbClr val="1A1A2E"/>
+                </a:solidFill>
+                <a:latin typeface="Calibri"/>
+              </a:rPr>
+              <a:t>6 870 t</a:t>
+            </a:r>
+          </a:p>
+        </p:txBody>
+      </p:sp>
+      <p:sp>
+        <p:nvSpPr>
+          <p:cNvPr id="19" name="TextBox 18"/>
+          <p:cNvSpPr txBox="1"/>
+          <p:nvPr/>
+        </p:nvSpPr>
+        <p:spPr>
+          <a:xfrm>
+            <a:off x="4572000" y="2414016"/>
+            <a:ext cx="3383280" cy="566928"/>
+          </a:xfrm>
+          <a:prstGeom prst="rect">
+            <a:avLst/>
+          </a:prstGeom>
+          <a:noFill/>
+        </p:spPr>
+        <p:txBody>
+          <a:bodyPr wrap="square" lIns="45720" rIns="45720" anchor="t">
+            <a:spAutoFit/>
+          </a:bodyPr>
+          <a:lstStyle/>
+          <a:p>
+            <a:pPr algn="l"/>
+            <a:r>
+              <a:rPr sz="1000" b="0">
+                <a:solidFill>
+                  <a:srgbClr val="2CA02C"/>
+                </a:solidFill>
+                <a:latin typeface="Calibri"/>
+              </a:rPr>
+              <a:t>CAPPELLE-BROUCK (5.51 km)</a:t>
+            </a:r>
+          </a:p>
+          <a:p>
+            <a:pPr algn="l"/>
+            <a:r>
+              <a:rPr sz="1000" b="0">
+                <a:solidFill>
+                  <a:srgbClr val="2CA02C"/>
+                </a:solidFill>
+                <a:latin typeface="Calibri"/>
+              </a:rPr>
+              <a:t>LEDERZEELE (6.63 km)</a:t>
+            </a:r>
+          </a:p>
+        </p:txBody>
+      </p:sp>
+      <p:sp>
+        <p:nvSpPr>
+          <p:cNvPr id="20" name="TextBox 19"/>
+          <p:cNvSpPr txBox="1"/>
+          <p:nvPr/>
+        </p:nvSpPr>
+        <p:spPr>
+          <a:xfrm>
+            <a:off x="7955279" y="2414016"/>
+            <a:ext cx="3291840" cy="566928"/>
+          </a:xfrm>
+          <a:prstGeom prst="rect">
+            <a:avLst/>
+          </a:prstGeom>
+          <a:noFill/>
+        </p:spPr>
+        <p:txBody>
+          <a:bodyPr wrap="square" lIns="45720" rIns="45720" anchor="t">
+            <a:spAutoFit/>
+          </a:bodyPr>
+          <a:lstStyle/>
+          <a:p>
+            <a:pPr algn="l"/>
+            <a:r>
+              <a:rPr sz="1000" b="0">
+                <a:solidFill>
+                  <a:srgbClr val="B0B0B8"/>
+                </a:solidFill>
+                <a:latin typeface="Calibri"/>
+              </a:rPr>
+              <a:t>—</a:t>
+            </a:r>
+          </a:p>
+        </p:txBody>
+      </p:sp>
+      <p:sp>
+        <p:nvSpPr>
+          <p:cNvPr id="21" name="Rectangle 20"/>
+          <p:cNvSpPr/>
+          <p:nvPr/>
+        </p:nvSpPr>
+        <p:spPr>
+          <a:xfrm>
+            <a:off x="457200" y="2935224"/>
+            <a:ext cx="11277295" cy="566928"/>
+          </a:xfrm>
+          <a:prstGeom prst="rect">
+            <a:avLst/>
+          </a:prstGeom>
+          <a:solidFill>
+            <a:srgbClr val="F4F4F6"/>
+          </a:solidFill>
+          <a:ln>
+            <a:noFill/>
+          </a:ln>
+          <a:effectLst/>
+        </p:spPr>
+        <p:style>
+          <a:lnRef idx="1">
+            <a:schemeClr val="accent1"/>
+          </a:lnRef>
+          <a:fillRef idx="3">
+            <a:schemeClr val="accent1"/>
+          </a:fillRef>
+          <a:effectRef idx="2">
+            <a:schemeClr val="accent1"/>
+          </a:effectRef>
+          <a:fontRef idx="minor">
+            <a:schemeClr val="lt1"/>
+          </a:fontRef>
+        </p:style>
+        <p:txBody>
+          <a:bodyPr rtlCol="0" anchor="ctr"/>
+          <a:lstStyle/>
+          <a:p>
+            <a:pPr algn="ctr"/>
+          </a:p>
+        </p:txBody>
+      </p:sp>
+      <p:sp>
+        <p:nvSpPr>
+          <p:cNvPr id="22" name="Rectangle 21"/>
+          <p:cNvSpPr/>
+          <p:nvPr/>
+        </p:nvSpPr>
+        <p:spPr>
+          <a:xfrm>
+            <a:off x="457200" y="2935224"/>
             <a:ext cx="73152" cy="566928"/>
           </a:xfrm>
           <a:prstGeom prst="rect">
@@ -11866,13 +12118,13 @@
       </p:sp>
       <p:sp>
         <p:nvSpPr>
-          <p:cNvPr id="17" name="TextBox 16"/>
-          <p:cNvSpPr txBox="1"/>
-          <p:nvPr/>
-        </p:nvSpPr>
-        <p:spPr>
-          <a:xfrm>
-            <a:off x="548640" y="2212848"/>
+          <p:cNvPr id="23" name="TextBox 22"/>
+          <p:cNvSpPr txBox="1"/>
+          <p:nvPr/>
+        </p:nvSpPr>
+        <p:spPr>
+          <a:xfrm>
+            <a:off x="548640" y="2980944"/>
             <a:ext cx="2651760" cy="566928"/>
           </a:xfrm>
           <a:prstGeom prst="rect">
@@ -11901,13 +12153,13 @@
       </p:sp>
       <p:sp>
         <p:nvSpPr>
-          <p:cNvPr id="18" name="TextBox 17"/>
-          <p:cNvSpPr txBox="1"/>
-          <p:nvPr/>
-        </p:nvSpPr>
-        <p:spPr>
-          <a:xfrm>
-            <a:off x="3200400" y="2212848"/>
+          <p:cNvPr id="24" name="TextBox 23"/>
+          <p:cNvSpPr txBox="1"/>
+          <p:nvPr/>
+        </p:nvSpPr>
+        <p:spPr>
+          <a:xfrm>
+            <a:off x="3200400" y="2980944"/>
             <a:ext cx="1371600" cy="566928"/>
           </a:xfrm>
           <a:prstGeom prst="rect">
@@ -11936,13 +12188,13 @@
       </p:sp>
       <p:sp>
         <p:nvSpPr>
-          <p:cNvPr id="19" name="TextBox 18"/>
-          <p:cNvSpPr txBox="1"/>
-          <p:nvPr/>
-        </p:nvSpPr>
-        <p:spPr>
-          <a:xfrm>
-            <a:off x="4572000" y="2212848"/>
+          <p:cNvPr id="25" name="TextBox 24"/>
+          <p:cNvSpPr txBox="1"/>
+          <p:nvPr/>
+        </p:nvSpPr>
+        <p:spPr>
+          <a:xfrm>
+            <a:off x="4572000" y="2980944"/>
             <a:ext cx="3383280" cy="566928"/>
           </a:xfrm>
           <a:prstGeom prst="rect">
@@ -11983,13 +12235,13 @@
       </p:sp>
       <p:sp>
         <p:nvSpPr>
-          <p:cNvPr id="20" name="TextBox 19"/>
-          <p:cNvSpPr txBox="1"/>
-          <p:nvPr/>
-        </p:nvSpPr>
-        <p:spPr>
-          <a:xfrm>
-            <a:off x="7955279" y="2212848"/>
+          <p:cNvPr id="26" name="TextBox 25"/>
+          <p:cNvSpPr txBox="1"/>
+          <p:nvPr/>
+        </p:nvSpPr>
+        <p:spPr>
+          <a:xfrm>
+            <a:off x="7955279" y="2980944"/>
             <a:ext cx="3291840" cy="566928"/>
           </a:xfrm>
           <a:prstGeom prst="rect">
@@ -12018,13 +12270,197 @@
       </p:sp>
       <p:sp>
         <p:nvSpPr>
-          <p:cNvPr id="21" name="Rectangle 20"/>
+          <p:cNvPr id="27" name="Rectangle 26"/>
           <p:cNvSpPr/>
           <p:nvPr/>
         </p:nvSpPr>
         <p:spPr>
           <a:xfrm>
-            <a:off x="457200" y="2734056"/>
+            <a:off x="457200" y="3502152"/>
+            <a:ext cx="73152" cy="365760"/>
+          </a:xfrm>
+          <a:prstGeom prst="rect">
+            <a:avLst/>
+          </a:prstGeom>
+          <a:solidFill>
+            <a:srgbClr val="9C27B0"/>
+          </a:solidFill>
+          <a:ln>
+            <a:noFill/>
+          </a:ln>
+          <a:effectLst/>
+        </p:spPr>
+        <p:style>
+          <a:lnRef idx="1">
+            <a:schemeClr val="accent1"/>
+          </a:lnRef>
+          <a:fillRef idx="3">
+            <a:schemeClr val="accent1"/>
+          </a:fillRef>
+          <a:effectRef idx="2">
+            <a:schemeClr val="accent1"/>
+          </a:effectRef>
+          <a:fontRef idx="minor">
+            <a:schemeClr val="lt1"/>
+          </a:fontRef>
+        </p:style>
+        <p:txBody>
+          <a:bodyPr rtlCol="0" anchor="ctr"/>
+          <a:lstStyle/>
+          <a:p>
+            <a:pPr algn="ctr"/>
+          </a:p>
+        </p:txBody>
+      </p:sp>
+      <p:sp>
+        <p:nvSpPr>
+          <p:cNvPr id="28" name="TextBox 27"/>
+          <p:cNvSpPr txBox="1"/>
+          <p:nvPr/>
+        </p:nvSpPr>
+        <p:spPr>
+          <a:xfrm>
+            <a:off x="548640" y="3547872"/>
+            <a:ext cx="2651760" cy="365760"/>
+          </a:xfrm>
+          <a:prstGeom prst="rect">
+            <a:avLst/>
+          </a:prstGeom>
+          <a:noFill/>
+        </p:spPr>
+        <p:txBody>
+          <a:bodyPr wrap="square" lIns="45720" rIns="45720" anchor="t">
+            <a:spAutoFit/>
+          </a:bodyPr>
+          <a:lstStyle/>
+          <a:p>
+            <a:pPr algn="l"/>
+            <a:r>
+              <a:rPr sz="1200" b="1">
+                <a:solidFill>
+                  <a:srgbClr val="1A1A2E"/>
+                </a:solidFill>
+                <a:latin typeface="Calibri"/>
+              </a:rPr>
+              <a:t>SOCX</a:t>
+            </a:r>
+          </a:p>
+        </p:txBody>
+      </p:sp>
+      <p:sp>
+        <p:nvSpPr>
+          <p:cNvPr id="29" name="TextBox 28"/>
+          <p:cNvSpPr txBox="1"/>
+          <p:nvPr/>
+        </p:nvSpPr>
+        <p:spPr>
+          <a:xfrm>
+            <a:off x="3200400" y="3547872"/>
+            <a:ext cx="1371600" cy="365760"/>
+          </a:xfrm>
+          <a:prstGeom prst="rect">
+            <a:avLst/>
+          </a:prstGeom>
+          <a:noFill/>
+        </p:spPr>
+        <p:txBody>
+          <a:bodyPr wrap="square" lIns="45720" rIns="45720" anchor="t">
+            <a:spAutoFit/>
+          </a:bodyPr>
+          <a:lstStyle/>
+          <a:p>
+            <a:pPr algn="l"/>
+            <a:r>
+              <a:rPr sz="1200" b="0">
+                <a:solidFill>
+                  <a:srgbClr val="1A1A2E"/>
+                </a:solidFill>
+                <a:latin typeface="Calibri"/>
+              </a:rPr>
+              <a:t>6 074 t</a:t>
+            </a:r>
+          </a:p>
+        </p:txBody>
+      </p:sp>
+      <p:sp>
+        <p:nvSpPr>
+          <p:cNvPr id="30" name="TextBox 29"/>
+          <p:cNvSpPr txBox="1"/>
+          <p:nvPr/>
+        </p:nvSpPr>
+        <p:spPr>
+          <a:xfrm>
+            <a:off x="4572000" y="3547872"/>
+            <a:ext cx="3383280" cy="365760"/>
+          </a:xfrm>
+          <a:prstGeom prst="rect">
+            <a:avLst/>
+          </a:prstGeom>
+          <a:noFill/>
+        </p:spPr>
+        <p:txBody>
+          <a:bodyPr wrap="square" lIns="45720" rIns="45720" anchor="t">
+            <a:spAutoFit/>
+          </a:bodyPr>
+          <a:lstStyle/>
+          <a:p>
+            <a:pPr algn="l"/>
+            <a:r>
+              <a:rPr sz="1000" b="0">
+                <a:solidFill>
+                  <a:srgbClr val="2CA02C"/>
+                </a:solidFill>
+                <a:latin typeface="Calibri"/>
+              </a:rPr>
+              <a:t>ESQUELBECQ (6.69 km)</a:t>
+            </a:r>
+          </a:p>
+        </p:txBody>
+      </p:sp>
+      <p:sp>
+        <p:nvSpPr>
+          <p:cNvPr id="31" name="TextBox 30"/>
+          <p:cNvSpPr txBox="1"/>
+          <p:nvPr/>
+        </p:nvSpPr>
+        <p:spPr>
+          <a:xfrm>
+            <a:off x="7955279" y="3547872"/>
+            <a:ext cx="3291840" cy="365760"/>
+          </a:xfrm>
+          <a:prstGeom prst="rect">
+            <a:avLst/>
+          </a:prstGeom>
+          <a:noFill/>
+        </p:spPr>
+        <p:txBody>
+          <a:bodyPr wrap="square" lIns="45720" rIns="45720" anchor="t">
+            <a:spAutoFit/>
+          </a:bodyPr>
+          <a:lstStyle/>
+          <a:p>
+            <a:pPr algn="l"/>
+            <a:r>
+              <a:rPr sz="1000" b="0">
+                <a:solidFill>
+                  <a:srgbClr val="1F77B4"/>
+                </a:solidFill>
+                <a:latin typeface="Calibri"/>
+              </a:rPr>
+              <a:t>BIERNE (2.08 km)</a:t>
+            </a:r>
+          </a:p>
+        </p:txBody>
+      </p:sp>
+      <p:sp>
+        <p:nvSpPr>
+          <p:cNvPr id="32" name="Rectangle 31"/>
+          <p:cNvSpPr/>
+          <p:nvPr/>
+        </p:nvSpPr>
+        <p:spPr>
+          <a:xfrm>
+            <a:off x="457200" y="3867912"/>
             <a:ext cx="11277295" cy="365760"/>
           </a:xfrm>
           <a:prstGeom prst="rect">
@@ -12062,13 +12498,621 @@
       </p:sp>
       <p:sp>
         <p:nvSpPr>
-          <p:cNvPr id="22" name="Rectangle 21"/>
+          <p:cNvPr id="33" name="Rectangle 32"/>
           <p:cNvSpPr/>
           <p:nvPr/>
         </p:nvSpPr>
         <p:spPr>
           <a:xfrm>
-            <a:off x="457200" y="2734056"/>
+            <a:off x="457200" y="3867912"/>
+            <a:ext cx="73152" cy="365760"/>
+          </a:xfrm>
+          <a:prstGeom prst="rect">
+            <a:avLst/>
+          </a:prstGeom>
+          <a:solidFill>
+            <a:srgbClr val="2CA02C"/>
+          </a:solidFill>
+          <a:ln>
+            <a:noFill/>
+          </a:ln>
+          <a:effectLst/>
+        </p:spPr>
+        <p:style>
+          <a:lnRef idx="1">
+            <a:schemeClr val="accent1"/>
+          </a:lnRef>
+          <a:fillRef idx="3">
+            <a:schemeClr val="accent1"/>
+          </a:fillRef>
+          <a:effectRef idx="2">
+            <a:schemeClr val="accent1"/>
+          </a:effectRef>
+          <a:fontRef idx="minor">
+            <a:schemeClr val="lt1"/>
+          </a:fontRef>
+        </p:style>
+        <p:txBody>
+          <a:bodyPr rtlCol="0" anchor="ctr"/>
+          <a:lstStyle/>
+          <a:p>
+            <a:pPr algn="ctr"/>
+          </a:p>
+        </p:txBody>
+      </p:sp>
+      <p:sp>
+        <p:nvSpPr>
+          <p:cNvPr id="34" name="TextBox 33"/>
+          <p:cNvSpPr txBox="1"/>
+          <p:nvPr/>
+        </p:nvSpPr>
+        <p:spPr>
+          <a:xfrm>
+            <a:off x="548640" y="3913632"/>
+            <a:ext cx="2651760" cy="365760"/>
+          </a:xfrm>
+          <a:prstGeom prst="rect">
+            <a:avLst/>
+          </a:prstGeom>
+          <a:noFill/>
+        </p:spPr>
+        <p:txBody>
+          <a:bodyPr wrap="square" lIns="45720" rIns="45720" anchor="t">
+            <a:spAutoFit/>
+          </a:bodyPr>
+          <a:lstStyle/>
+          <a:p>
+            <a:pPr algn="l"/>
+            <a:r>
+              <a:rPr sz="1200" b="1">
+                <a:solidFill>
+                  <a:srgbClr val="1A1A2E"/>
+                </a:solidFill>
+                <a:latin typeface="Calibri"/>
+              </a:rPr>
+              <a:t>GUINES</a:t>
+            </a:r>
+          </a:p>
+        </p:txBody>
+      </p:sp>
+      <p:sp>
+        <p:nvSpPr>
+          <p:cNvPr id="35" name="TextBox 34"/>
+          <p:cNvSpPr txBox="1"/>
+          <p:nvPr/>
+        </p:nvSpPr>
+        <p:spPr>
+          <a:xfrm>
+            <a:off x="3200400" y="3913632"/>
+            <a:ext cx="1371600" cy="365760"/>
+          </a:xfrm>
+          <a:prstGeom prst="rect">
+            <a:avLst/>
+          </a:prstGeom>
+          <a:noFill/>
+        </p:spPr>
+        <p:txBody>
+          <a:bodyPr wrap="square" lIns="45720" rIns="45720" anchor="t">
+            <a:spAutoFit/>
+          </a:bodyPr>
+          <a:lstStyle/>
+          <a:p>
+            <a:pPr algn="l"/>
+            <a:r>
+              <a:rPr sz="1200" b="0">
+                <a:solidFill>
+                  <a:srgbClr val="1A1A2E"/>
+                </a:solidFill>
+                <a:latin typeface="Calibri"/>
+              </a:rPr>
+              <a:t>5 212 t</a:t>
+            </a:r>
+          </a:p>
+        </p:txBody>
+      </p:sp>
+      <p:sp>
+        <p:nvSpPr>
+          <p:cNvPr id="36" name="TextBox 35"/>
+          <p:cNvSpPr txBox="1"/>
+          <p:nvPr/>
+        </p:nvSpPr>
+        <p:spPr>
+          <a:xfrm>
+            <a:off x="4572000" y="3913632"/>
+            <a:ext cx="3383280" cy="365760"/>
+          </a:xfrm>
+          <a:prstGeom prst="rect">
+            <a:avLst/>
+          </a:prstGeom>
+          <a:noFill/>
+        </p:spPr>
+        <p:txBody>
+          <a:bodyPr wrap="square" lIns="45720" rIns="45720" anchor="t">
+            <a:spAutoFit/>
+          </a:bodyPr>
+          <a:lstStyle/>
+          <a:p>
+            <a:pPr algn="l"/>
+            <a:r>
+              <a:rPr sz="1000" b="0">
+                <a:solidFill>
+                  <a:srgbClr val="2CA02C"/>
+                </a:solidFill>
+                <a:latin typeface="Calibri"/>
+              </a:rPr>
+              <a:t>CAFFIERS (4.06 km)</a:t>
+            </a:r>
+          </a:p>
+        </p:txBody>
+      </p:sp>
+      <p:sp>
+        <p:nvSpPr>
+          <p:cNvPr id="37" name="TextBox 36"/>
+          <p:cNvSpPr txBox="1"/>
+          <p:nvPr/>
+        </p:nvSpPr>
+        <p:spPr>
+          <a:xfrm>
+            <a:off x="7955279" y="3913632"/>
+            <a:ext cx="3291840" cy="365760"/>
+          </a:xfrm>
+          <a:prstGeom prst="rect">
+            <a:avLst/>
+          </a:prstGeom>
+          <a:noFill/>
+        </p:spPr>
+        <p:txBody>
+          <a:bodyPr wrap="square" lIns="45720" rIns="45720" anchor="t">
+            <a:spAutoFit/>
+          </a:bodyPr>
+          <a:lstStyle/>
+          <a:p>
+            <a:pPr algn="l"/>
+            <a:r>
+              <a:rPr sz="1000" b="0">
+                <a:solidFill>
+                  <a:srgbClr val="B0B0B8"/>
+                </a:solidFill>
+                <a:latin typeface="Calibri"/>
+              </a:rPr>
+              <a:t>—</a:t>
+            </a:r>
+          </a:p>
+        </p:txBody>
+      </p:sp>
+      <p:sp>
+        <p:nvSpPr>
+          <p:cNvPr id="38" name="Rectangle 37"/>
+          <p:cNvSpPr/>
+          <p:nvPr/>
+        </p:nvSpPr>
+        <p:spPr>
+          <a:xfrm>
+            <a:off x="457200" y="4233672"/>
+            <a:ext cx="73152" cy="566928"/>
+          </a:xfrm>
+          <a:prstGeom prst="rect">
+            <a:avLst/>
+          </a:prstGeom>
+          <a:solidFill>
+            <a:srgbClr val="2CA02C"/>
+          </a:solidFill>
+          <a:ln>
+            <a:noFill/>
+          </a:ln>
+          <a:effectLst/>
+        </p:spPr>
+        <p:style>
+          <a:lnRef idx="1">
+            <a:schemeClr val="accent1"/>
+          </a:lnRef>
+          <a:fillRef idx="3">
+            <a:schemeClr val="accent1"/>
+          </a:fillRef>
+          <a:effectRef idx="2">
+            <a:schemeClr val="accent1"/>
+          </a:effectRef>
+          <a:fontRef idx="minor">
+            <a:schemeClr val="lt1"/>
+          </a:fontRef>
+        </p:style>
+        <p:txBody>
+          <a:bodyPr rtlCol="0" anchor="ctr"/>
+          <a:lstStyle/>
+          <a:p>
+            <a:pPr algn="ctr"/>
+          </a:p>
+        </p:txBody>
+      </p:sp>
+      <p:sp>
+        <p:nvSpPr>
+          <p:cNvPr id="39" name="TextBox 38"/>
+          <p:cNvSpPr txBox="1"/>
+          <p:nvPr/>
+        </p:nvSpPr>
+        <p:spPr>
+          <a:xfrm>
+            <a:off x="548640" y="4279392"/>
+            <a:ext cx="2651760" cy="566928"/>
+          </a:xfrm>
+          <a:prstGeom prst="rect">
+            <a:avLst/>
+          </a:prstGeom>
+          <a:noFill/>
+        </p:spPr>
+        <p:txBody>
+          <a:bodyPr wrap="square" lIns="45720" rIns="45720" anchor="t">
+            <a:spAutoFit/>
+          </a:bodyPr>
+          <a:lstStyle/>
+          <a:p>
+            <a:pPr algn="l"/>
+            <a:r>
+              <a:rPr sz="1200" b="1">
+                <a:solidFill>
+                  <a:srgbClr val="1A1A2E"/>
+                </a:solidFill>
+                <a:latin typeface="Calibri"/>
+              </a:rPr>
+              <a:t>LAMBRES-LEZ-AIRE</a:t>
+            </a:r>
+          </a:p>
+        </p:txBody>
+      </p:sp>
+      <p:sp>
+        <p:nvSpPr>
+          <p:cNvPr id="40" name="TextBox 39"/>
+          <p:cNvSpPr txBox="1"/>
+          <p:nvPr/>
+        </p:nvSpPr>
+        <p:spPr>
+          <a:xfrm>
+            <a:off x="3200400" y="4279392"/>
+            <a:ext cx="1371600" cy="566928"/>
+          </a:xfrm>
+          <a:prstGeom prst="rect">
+            <a:avLst/>
+          </a:prstGeom>
+          <a:noFill/>
+        </p:spPr>
+        <p:txBody>
+          <a:bodyPr wrap="square" lIns="45720" rIns="45720" anchor="t">
+            <a:spAutoFit/>
+          </a:bodyPr>
+          <a:lstStyle/>
+          <a:p>
+            <a:pPr algn="l"/>
+            <a:r>
+              <a:rPr sz="1200" b="0">
+                <a:solidFill>
+                  <a:srgbClr val="1A1A2E"/>
+                </a:solidFill>
+                <a:latin typeface="Calibri"/>
+              </a:rPr>
+              <a:t>5 196 t</a:t>
+            </a:r>
+          </a:p>
+        </p:txBody>
+      </p:sp>
+      <p:sp>
+        <p:nvSpPr>
+          <p:cNvPr id="41" name="TextBox 40"/>
+          <p:cNvSpPr txBox="1"/>
+          <p:nvPr/>
+        </p:nvSpPr>
+        <p:spPr>
+          <a:xfrm>
+            <a:off x="4572000" y="4279392"/>
+            <a:ext cx="3383280" cy="566928"/>
+          </a:xfrm>
+          <a:prstGeom prst="rect">
+            <a:avLst/>
+          </a:prstGeom>
+          <a:noFill/>
+        </p:spPr>
+        <p:txBody>
+          <a:bodyPr wrap="square" lIns="45720" rIns="45720" anchor="t">
+            <a:spAutoFit/>
+          </a:bodyPr>
+          <a:lstStyle/>
+          <a:p>
+            <a:pPr algn="l"/>
+            <a:r>
+              <a:rPr sz="1000" b="0">
+                <a:solidFill>
+                  <a:srgbClr val="2CA02C"/>
+                </a:solidFill>
+                <a:latin typeface="Calibri"/>
+              </a:rPr>
+              <a:t>AIRE SUR LA LYS (1.52 km)</a:t>
+            </a:r>
+          </a:p>
+          <a:p>
+            <a:pPr algn="l"/>
+            <a:r>
+              <a:rPr sz="1000" b="0">
+                <a:solidFill>
+                  <a:srgbClr val="2CA02C"/>
+                </a:solidFill>
+                <a:latin typeface="Calibri"/>
+              </a:rPr>
+              <a:t>AIRE SUR LA LYS (2.02 km)</a:t>
+            </a:r>
+          </a:p>
+        </p:txBody>
+      </p:sp>
+      <p:sp>
+        <p:nvSpPr>
+          <p:cNvPr id="42" name="TextBox 41"/>
+          <p:cNvSpPr txBox="1"/>
+          <p:nvPr/>
+        </p:nvSpPr>
+        <p:spPr>
+          <a:xfrm>
+            <a:off x="7955279" y="4279392"/>
+            <a:ext cx="3291840" cy="566928"/>
+          </a:xfrm>
+          <a:prstGeom prst="rect">
+            <a:avLst/>
+          </a:prstGeom>
+          <a:noFill/>
+        </p:spPr>
+        <p:txBody>
+          <a:bodyPr wrap="square" lIns="45720" rIns="45720" anchor="t">
+            <a:spAutoFit/>
+          </a:bodyPr>
+          <a:lstStyle/>
+          <a:p>
+            <a:pPr algn="l"/>
+            <a:r>
+              <a:rPr sz="1000" b="0">
+                <a:solidFill>
+                  <a:srgbClr val="B0B0B8"/>
+                </a:solidFill>
+                <a:latin typeface="Calibri"/>
+              </a:rPr>
+              <a:t>—</a:t>
+            </a:r>
+          </a:p>
+        </p:txBody>
+      </p:sp>
+      <p:sp>
+        <p:nvSpPr>
+          <p:cNvPr id="43" name="Rectangle 42"/>
+          <p:cNvSpPr/>
+          <p:nvPr/>
+        </p:nvSpPr>
+        <p:spPr>
+          <a:xfrm>
+            <a:off x="457200" y="4800600"/>
+            <a:ext cx="11277295" cy="365760"/>
+          </a:xfrm>
+          <a:prstGeom prst="rect">
+            <a:avLst/>
+          </a:prstGeom>
+          <a:solidFill>
+            <a:srgbClr val="F4F4F6"/>
+          </a:solidFill>
+          <a:ln>
+            <a:noFill/>
+          </a:ln>
+          <a:effectLst/>
+        </p:spPr>
+        <p:style>
+          <a:lnRef idx="1">
+            <a:schemeClr val="accent1"/>
+          </a:lnRef>
+          <a:fillRef idx="3">
+            <a:schemeClr val="accent1"/>
+          </a:fillRef>
+          <a:effectRef idx="2">
+            <a:schemeClr val="accent1"/>
+          </a:effectRef>
+          <a:fontRef idx="minor">
+            <a:schemeClr val="lt1"/>
+          </a:fontRef>
+        </p:style>
+        <p:txBody>
+          <a:bodyPr rtlCol="0" anchor="ctr"/>
+          <a:lstStyle/>
+          <a:p>
+            <a:pPr algn="ctr"/>
+          </a:p>
+        </p:txBody>
+      </p:sp>
+      <p:sp>
+        <p:nvSpPr>
+          <p:cNvPr id="44" name="Rectangle 43"/>
+          <p:cNvSpPr/>
+          <p:nvPr/>
+        </p:nvSpPr>
+        <p:spPr>
+          <a:xfrm>
+            <a:off x="457200" y="4800600"/>
+            <a:ext cx="73152" cy="365760"/>
+          </a:xfrm>
+          <a:prstGeom prst="rect">
+            <a:avLst/>
+          </a:prstGeom>
+          <a:solidFill>
+            <a:srgbClr val="2CA02C"/>
+          </a:solidFill>
+          <a:ln>
+            <a:noFill/>
+          </a:ln>
+          <a:effectLst/>
+        </p:spPr>
+        <p:style>
+          <a:lnRef idx="1">
+            <a:schemeClr val="accent1"/>
+          </a:lnRef>
+          <a:fillRef idx="3">
+            <a:schemeClr val="accent1"/>
+          </a:fillRef>
+          <a:effectRef idx="2">
+            <a:schemeClr val="accent1"/>
+          </a:effectRef>
+          <a:fontRef idx="minor">
+            <a:schemeClr val="lt1"/>
+          </a:fontRef>
+        </p:style>
+        <p:txBody>
+          <a:bodyPr rtlCol="0" anchor="ctr"/>
+          <a:lstStyle/>
+          <a:p>
+            <a:pPr algn="ctr"/>
+          </a:p>
+        </p:txBody>
+      </p:sp>
+      <p:sp>
+        <p:nvSpPr>
+          <p:cNvPr id="45" name="TextBox 44"/>
+          <p:cNvSpPr txBox="1"/>
+          <p:nvPr/>
+        </p:nvSpPr>
+        <p:spPr>
+          <a:xfrm>
+            <a:off x="548640" y="4846320"/>
+            <a:ext cx="2651760" cy="365760"/>
+          </a:xfrm>
+          <a:prstGeom prst="rect">
+            <a:avLst/>
+          </a:prstGeom>
+          <a:noFill/>
+        </p:spPr>
+        <p:txBody>
+          <a:bodyPr wrap="square" lIns="45720" rIns="45720" anchor="t">
+            <a:spAutoFit/>
+          </a:bodyPr>
+          <a:lstStyle/>
+          <a:p>
+            <a:pPr algn="l"/>
+            <a:r>
+              <a:rPr sz="1200" b="1">
+                <a:solidFill>
+                  <a:srgbClr val="1A1A2E"/>
+                </a:solidFill>
+                <a:latin typeface="Calibri"/>
+              </a:rPr>
+              <a:t>BOLLEZEELE</a:t>
+            </a:r>
+          </a:p>
+        </p:txBody>
+      </p:sp>
+      <p:sp>
+        <p:nvSpPr>
+          <p:cNvPr id="46" name="TextBox 45"/>
+          <p:cNvSpPr txBox="1"/>
+          <p:nvPr/>
+        </p:nvSpPr>
+        <p:spPr>
+          <a:xfrm>
+            <a:off x="3200400" y="4846320"/>
+            <a:ext cx="1371600" cy="365760"/>
+          </a:xfrm>
+          <a:prstGeom prst="rect">
+            <a:avLst/>
+          </a:prstGeom>
+          <a:noFill/>
+        </p:spPr>
+        <p:txBody>
+          <a:bodyPr wrap="square" lIns="45720" rIns="45720" anchor="t">
+            <a:spAutoFit/>
+          </a:bodyPr>
+          <a:lstStyle/>
+          <a:p>
+            <a:pPr algn="l"/>
+            <a:r>
+              <a:rPr sz="1200" b="0">
+                <a:solidFill>
+                  <a:srgbClr val="1A1A2E"/>
+                </a:solidFill>
+                <a:latin typeface="Calibri"/>
+              </a:rPr>
+              <a:t>4 437 t</a:t>
+            </a:r>
+          </a:p>
+        </p:txBody>
+      </p:sp>
+      <p:sp>
+        <p:nvSpPr>
+          <p:cNvPr id="47" name="TextBox 46"/>
+          <p:cNvSpPr txBox="1"/>
+          <p:nvPr/>
+        </p:nvSpPr>
+        <p:spPr>
+          <a:xfrm>
+            <a:off x="4572000" y="4846320"/>
+            <a:ext cx="3383280" cy="365760"/>
+          </a:xfrm>
+          <a:prstGeom prst="rect">
+            <a:avLst/>
+          </a:prstGeom>
+          <a:noFill/>
+        </p:spPr>
+        <p:txBody>
+          <a:bodyPr wrap="square" lIns="45720" rIns="45720" anchor="t">
+            <a:spAutoFit/>
+          </a:bodyPr>
+          <a:lstStyle/>
+          <a:p>
+            <a:pPr algn="l"/>
+            <a:r>
+              <a:rPr sz="1000" b="0">
+                <a:solidFill>
+                  <a:srgbClr val="2CA02C"/>
+                </a:solidFill>
+                <a:latin typeface="Calibri"/>
+              </a:rPr>
+              <a:t>LEDERZEELE (6.14 km)</a:t>
+            </a:r>
+          </a:p>
+        </p:txBody>
+      </p:sp>
+      <p:sp>
+        <p:nvSpPr>
+          <p:cNvPr id="48" name="TextBox 47"/>
+          <p:cNvSpPr txBox="1"/>
+          <p:nvPr/>
+        </p:nvSpPr>
+        <p:spPr>
+          <a:xfrm>
+            <a:off x="7955279" y="4846320"/>
+            <a:ext cx="3291840" cy="365760"/>
+          </a:xfrm>
+          <a:prstGeom prst="rect">
+            <a:avLst/>
+          </a:prstGeom>
+          <a:noFill/>
+        </p:spPr>
+        <p:txBody>
+          <a:bodyPr wrap="square" lIns="45720" rIns="45720" anchor="t">
+            <a:spAutoFit/>
+          </a:bodyPr>
+          <a:lstStyle/>
+          <a:p>
+            <a:pPr algn="l"/>
+            <a:r>
+              <a:rPr sz="1000" b="0">
+                <a:solidFill>
+                  <a:srgbClr val="B0B0B8"/>
+                </a:solidFill>
+                <a:latin typeface="Calibri"/>
+              </a:rPr>
+              <a:t>—</a:t>
+            </a:r>
+          </a:p>
+        </p:txBody>
+      </p:sp>
+      <p:sp>
+        <p:nvSpPr>
+          <p:cNvPr id="49" name="Rectangle 48"/>
+          <p:cNvSpPr/>
+          <p:nvPr/>
+        </p:nvSpPr>
+        <p:spPr>
+          <a:xfrm>
+            <a:off x="457200" y="5166360"/>
             <a:ext cx="73152" cy="365760"/>
           </a:xfrm>
           <a:prstGeom prst="rect">
@@ -12106,13 +13150,13 @@
       </p:sp>
       <p:sp>
         <p:nvSpPr>
-          <p:cNvPr id="23" name="TextBox 22"/>
-          <p:cNvSpPr txBox="1"/>
-          <p:nvPr/>
-        </p:nvSpPr>
-        <p:spPr>
-          <a:xfrm>
-            <a:off x="548640" y="2779776"/>
+          <p:cNvPr id="50" name="TextBox 49"/>
+          <p:cNvSpPr txBox="1"/>
+          <p:nvPr/>
+        </p:nvSpPr>
+        <p:spPr>
+          <a:xfrm>
+            <a:off x="548640" y="5212080"/>
             <a:ext cx="2651760" cy="365760"/>
           </a:xfrm>
           <a:prstGeom prst="rect">
@@ -12134,20 +13178,20 @@
                 </a:solidFill>
                 <a:latin typeface="Calibri"/>
               </a:rPr>
-              <a:t>SOCX</a:t>
-            </a:r>
-          </a:p>
-        </p:txBody>
-      </p:sp>
-      <p:sp>
-        <p:nvSpPr>
-          <p:cNvPr id="24" name="TextBox 23"/>
-          <p:cNvSpPr txBox="1"/>
-          <p:nvPr/>
-        </p:nvSpPr>
-        <p:spPr>
-          <a:xfrm>
-            <a:off x="3200400" y="2779776"/>
+              <a:t>LOOBERGHE</a:t>
+            </a:r>
+          </a:p>
+        </p:txBody>
+      </p:sp>
+      <p:sp>
+        <p:nvSpPr>
+          <p:cNvPr id="51" name="TextBox 50"/>
+          <p:cNvSpPr txBox="1"/>
+          <p:nvPr/>
+        </p:nvSpPr>
+        <p:spPr>
+          <a:xfrm>
+            <a:off x="3200400" y="5212080"/>
             <a:ext cx="1371600" cy="365760"/>
           </a:xfrm>
           <a:prstGeom prst="rect">
@@ -12169,20 +13213,20 @@
                 </a:solidFill>
                 <a:latin typeface="Calibri"/>
               </a:rPr>
-              <a:t>6 074 t</a:t>
-            </a:r>
-          </a:p>
-        </p:txBody>
-      </p:sp>
-      <p:sp>
-        <p:nvSpPr>
-          <p:cNvPr id="25" name="TextBox 24"/>
-          <p:cNvSpPr txBox="1"/>
-          <p:nvPr/>
-        </p:nvSpPr>
-        <p:spPr>
-          <a:xfrm>
-            <a:off x="4572000" y="2779776"/>
+              <a:t>3 914 t</a:t>
+            </a:r>
+          </a:p>
+        </p:txBody>
+      </p:sp>
+      <p:sp>
+        <p:nvSpPr>
+          <p:cNvPr id="52" name="TextBox 51"/>
+          <p:cNvSpPr txBox="1"/>
+          <p:nvPr/>
+        </p:nvSpPr>
+        <p:spPr>
+          <a:xfrm>
+            <a:off x="4572000" y="5212080"/>
             <a:ext cx="3383280" cy="365760"/>
           </a:xfrm>
           <a:prstGeom prst="rect">
@@ -12204,20 +13248,20 @@
                 </a:solidFill>
                 <a:latin typeface="Calibri"/>
               </a:rPr>
-              <a:t>ESQUELBECQ (6.69 km)</a:t>
-            </a:r>
-          </a:p>
-        </p:txBody>
-      </p:sp>
-      <p:sp>
-        <p:nvSpPr>
-          <p:cNvPr id="26" name="TextBox 25"/>
-          <p:cNvSpPr txBox="1"/>
-          <p:nvPr/>
-        </p:nvSpPr>
-        <p:spPr>
-          <a:xfrm>
-            <a:off x="7955279" y="2779776"/>
+              <a:t>DUNKERQUE (6.74 km)</a:t>
+            </a:r>
+          </a:p>
+        </p:txBody>
+      </p:sp>
+      <p:sp>
+        <p:nvSpPr>
+          <p:cNvPr id="53" name="TextBox 52"/>
+          <p:cNvSpPr txBox="1"/>
+          <p:nvPr/>
+        </p:nvSpPr>
+        <p:spPr>
+          <a:xfrm>
+            <a:off x="7955279" y="5212080"/>
             <a:ext cx="3291840" cy="365760"/>
           </a:xfrm>
           <a:prstGeom prst="rect">
@@ -12239,21 +13283,249 @@
                 </a:solidFill>
                 <a:latin typeface="Calibri"/>
               </a:rPr>
-              <a:t>BIERNE (2.08 km)</a:t>
-            </a:r>
-          </a:p>
-        </p:txBody>
-      </p:sp>
-      <p:sp>
-        <p:nvSpPr>
-          <p:cNvPr id="27" name="Rectangle 26"/>
+              <a:t>BIERNE (0.92 km)</a:t>
+            </a:r>
+          </a:p>
+        </p:txBody>
+      </p:sp>
+      <p:sp>
+        <p:nvSpPr>
+          <p:cNvPr id="54" name="Rectangle 53"/>
           <p:cNvSpPr/>
           <p:nvPr/>
         </p:nvSpPr>
         <p:spPr>
           <a:xfrm>
-            <a:off x="457200" y="3099816"/>
-            <a:ext cx="73152" cy="566928"/>
+            <a:off x="457200" y="5532120"/>
+            <a:ext cx="11277295" cy="365760"/>
+          </a:xfrm>
+          <a:prstGeom prst="rect">
+            <a:avLst/>
+          </a:prstGeom>
+          <a:solidFill>
+            <a:srgbClr val="F4F4F6"/>
+          </a:solidFill>
+          <a:ln>
+            <a:noFill/>
+          </a:ln>
+          <a:effectLst/>
+        </p:spPr>
+        <p:style>
+          <a:lnRef idx="1">
+            <a:schemeClr val="accent1"/>
+          </a:lnRef>
+          <a:fillRef idx="3">
+            <a:schemeClr val="accent1"/>
+          </a:fillRef>
+          <a:effectRef idx="2">
+            <a:schemeClr val="accent1"/>
+          </a:effectRef>
+          <a:fontRef idx="minor">
+            <a:schemeClr val="lt1"/>
+          </a:fontRef>
+        </p:style>
+        <p:txBody>
+          <a:bodyPr rtlCol="0" anchor="ctr"/>
+          <a:lstStyle/>
+          <a:p>
+            <a:pPr algn="ctr"/>
+          </a:p>
+        </p:txBody>
+      </p:sp>
+      <p:sp>
+        <p:nvSpPr>
+          <p:cNvPr id="55" name="Rectangle 54"/>
+          <p:cNvSpPr/>
+          <p:nvPr/>
+        </p:nvSpPr>
+        <p:spPr>
+          <a:xfrm>
+            <a:off x="457200" y="5532120"/>
+            <a:ext cx="73152" cy="365760"/>
+          </a:xfrm>
+          <a:prstGeom prst="rect">
+            <a:avLst/>
+          </a:prstGeom>
+          <a:solidFill>
+            <a:srgbClr val="1F77B4"/>
+          </a:solidFill>
+          <a:ln>
+            <a:noFill/>
+          </a:ln>
+          <a:effectLst/>
+        </p:spPr>
+        <p:style>
+          <a:lnRef idx="1">
+            <a:schemeClr val="accent1"/>
+          </a:lnRef>
+          <a:fillRef idx="3">
+            <a:schemeClr val="accent1"/>
+          </a:fillRef>
+          <a:effectRef idx="2">
+            <a:schemeClr val="accent1"/>
+          </a:effectRef>
+          <a:fontRef idx="minor">
+            <a:schemeClr val="lt1"/>
+          </a:fontRef>
+        </p:style>
+        <p:txBody>
+          <a:bodyPr rtlCol="0" anchor="ctr"/>
+          <a:lstStyle/>
+          <a:p>
+            <a:pPr algn="ctr"/>
+          </a:p>
+        </p:txBody>
+      </p:sp>
+      <p:sp>
+        <p:nvSpPr>
+          <p:cNvPr id="56" name="TextBox 55"/>
+          <p:cNvSpPr txBox="1"/>
+          <p:nvPr/>
+        </p:nvSpPr>
+        <p:spPr>
+          <a:xfrm>
+            <a:off x="548640" y="5577840"/>
+            <a:ext cx="2651760" cy="365760"/>
+          </a:xfrm>
+          <a:prstGeom prst="rect">
+            <a:avLst/>
+          </a:prstGeom>
+          <a:noFill/>
+        </p:spPr>
+        <p:txBody>
+          <a:bodyPr wrap="square" lIns="45720" rIns="45720" anchor="t">
+            <a:spAutoFit/>
+          </a:bodyPr>
+          <a:lstStyle/>
+          <a:p>
+            <a:pPr algn="l"/>
+            <a:r>
+              <a:rPr sz="1200" b="1">
+                <a:solidFill>
+                  <a:srgbClr val="1A1A2E"/>
+                </a:solidFill>
+                <a:latin typeface="Calibri"/>
+              </a:rPr>
+              <a:t>OYE PLAGE</a:t>
+            </a:r>
+          </a:p>
+        </p:txBody>
+      </p:sp>
+      <p:sp>
+        <p:nvSpPr>
+          <p:cNvPr id="57" name="TextBox 56"/>
+          <p:cNvSpPr txBox="1"/>
+          <p:nvPr/>
+        </p:nvSpPr>
+        <p:spPr>
+          <a:xfrm>
+            <a:off x="3200400" y="5577840"/>
+            <a:ext cx="1371600" cy="365760"/>
+          </a:xfrm>
+          <a:prstGeom prst="rect">
+            <a:avLst/>
+          </a:prstGeom>
+          <a:noFill/>
+        </p:spPr>
+        <p:txBody>
+          <a:bodyPr wrap="square" lIns="45720" rIns="45720" anchor="t">
+            <a:spAutoFit/>
+          </a:bodyPr>
+          <a:lstStyle/>
+          <a:p>
+            <a:pPr algn="l"/>
+            <a:r>
+              <a:rPr sz="1200" b="0">
+                <a:solidFill>
+                  <a:srgbClr val="1A1A2E"/>
+                </a:solidFill>
+                <a:latin typeface="Calibri"/>
+              </a:rPr>
+              <a:t>3 670 t</a:t>
+            </a:r>
+          </a:p>
+        </p:txBody>
+      </p:sp>
+      <p:sp>
+        <p:nvSpPr>
+          <p:cNvPr id="58" name="TextBox 57"/>
+          <p:cNvSpPr txBox="1"/>
+          <p:nvPr/>
+        </p:nvSpPr>
+        <p:spPr>
+          <a:xfrm>
+            <a:off x="4572000" y="5577840"/>
+            <a:ext cx="3383280" cy="365760"/>
+          </a:xfrm>
+          <a:prstGeom prst="rect">
+            <a:avLst/>
+          </a:prstGeom>
+          <a:noFill/>
+        </p:spPr>
+        <p:txBody>
+          <a:bodyPr wrap="square" lIns="45720" rIns="45720" anchor="t">
+            <a:spAutoFit/>
+          </a:bodyPr>
+          <a:lstStyle/>
+          <a:p>
+            <a:pPr algn="l"/>
+            <a:r>
+              <a:rPr sz="1000" b="0">
+                <a:solidFill>
+                  <a:srgbClr val="B0B0B8"/>
+                </a:solidFill>
+                <a:latin typeface="Calibri"/>
+              </a:rPr>
+              <a:t>—</a:t>
+            </a:r>
+          </a:p>
+        </p:txBody>
+      </p:sp>
+      <p:sp>
+        <p:nvSpPr>
+          <p:cNvPr id="59" name="TextBox 58"/>
+          <p:cNvSpPr txBox="1"/>
+          <p:nvPr/>
+        </p:nvSpPr>
+        <p:spPr>
+          <a:xfrm>
+            <a:off x="7955279" y="5577840"/>
+            <a:ext cx="3291840" cy="365760"/>
+          </a:xfrm>
+          <a:prstGeom prst="rect">
+            <a:avLst/>
+          </a:prstGeom>
+          <a:noFill/>
+        </p:spPr>
+        <p:txBody>
+          <a:bodyPr wrap="square" lIns="45720" rIns="45720" anchor="t">
+            <a:spAutoFit/>
+          </a:bodyPr>
+          <a:lstStyle/>
+          <a:p>
+            <a:pPr algn="l"/>
+            <a:r>
+              <a:rPr sz="1000" b="0">
+                <a:solidFill>
+                  <a:srgbClr val="1F77B4"/>
+                </a:solidFill>
+                <a:latin typeface="Calibri"/>
+              </a:rPr>
+              <a:t>VIEILLE-EGLISE (6.57 km)</a:t>
+            </a:r>
+          </a:p>
+        </p:txBody>
+      </p:sp>
+      <p:sp>
+        <p:nvSpPr>
+          <p:cNvPr id="60" name="Rectangle 59"/>
+          <p:cNvSpPr/>
+          <p:nvPr/>
+        </p:nvSpPr>
+        <p:spPr>
+          <a:xfrm>
+            <a:off x="457200" y="5897880"/>
+            <a:ext cx="73152" cy="365760"/>
           </a:xfrm>
           <a:prstGeom prst="rect">
             <a:avLst/>
@@ -12290,14 +13562,14 @@
       </p:sp>
       <p:sp>
         <p:nvSpPr>
-          <p:cNvPr id="28" name="TextBox 27"/>
-          <p:cNvSpPr txBox="1"/>
-          <p:nvPr/>
-        </p:nvSpPr>
-        <p:spPr>
-          <a:xfrm>
-            <a:off x="548640" y="3145536"/>
-            <a:ext cx="2651760" cy="566928"/>
+          <p:cNvPr id="61" name="TextBox 60"/>
+          <p:cNvSpPr txBox="1"/>
+          <p:nvPr/>
+        </p:nvSpPr>
+        <p:spPr>
+          <a:xfrm>
+            <a:off x="548640" y="5943600"/>
+            <a:ext cx="2651760" cy="365760"/>
           </a:xfrm>
           <a:prstGeom prst="rect">
             <a:avLst/>
@@ -12318,21 +13590,21 @@
                 </a:solidFill>
                 <a:latin typeface="Calibri"/>
               </a:rPr>
-              <a:t>LAMBRES-LEZ-AIRE</a:t>
-            </a:r>
-          </a:p>
-        </p:txBody>
-      </p:sp>
-      <p:sp>
-        <p:nvSpPr>
-          <p:cNvPr id="29" name="TextBox 28"/>
-          <p:cNvSpPr txBox="1"/>
-          <p:nvPr/>
-        </p:nvSpPr>
-        <p:spPr>
-          <a:xfrm>
-            <a:off x="3200400" y="3145536"/>
-            <a:ext cx="1371600" cy="566928"/>
+              <a:t>LEDERZEELE</a:t>
+            </a:r>
+          </a:p>
+        </p:txBody>
+      </p:sp>
+      <p:sp>
+        <p:nvSpPr>
+          <p:cNvPr id="62" name="TextBox 61"/>
+          <p:cNvSpPr txBox="1"/>
+          <p:nvPr/>
+        </p:nvSpPr>
+        <p:spPr>
+          <a:xfrm>
+            <a:off x="3200400" y="5943600"/>
+            <a:ext cx="1371600" cy="365760"/>
           </a:xfrm>
           <a:prstGeom prst="rect">
             <a:avLst/>
@@ -12353,21 +13625,21 @@
                 </a:solidFill>
                 <a:latin typeface="Calibri"/>
               </a:rPr>
-              <a:t>5 196 t</a:t>
-            </a:r>
-          </a:p>
-        </p:txBody>
-      </p:sp>
-      <p:sp>
-        <p:nvSpPr>
-          <p:cNvPr id="30" name="TextBox 29"/>
-          <p:cNvSpPr txBox="1"/>
-          <p:nvPr/>
-        </p:nvSpPr>
-        <p:spPr>
-          <a:xfrm>
-            <a:off x="4572000" y="3145536"/>
-            <a:ext cx="3383280" cy="566928"/>
+              <a:t>3 156 t</a:t>
+            </a:r>
+          </a:p>
+        </p:txBody>
+      </p:sp>
+      <p:sp>
+        <p:nvSpPr>
+          <p:cNvPr id="63" name="TextBox 62"/>
+          <p:cNvSpPr txBox="1"/>
+          <p:nvPr/>
+        </p:nvSpPr>
+        <p:spPr>
+          <a:xfrm>
+            <a:off x="4572000" y="5943600"/>
+            <a:ext cx="3383280" cy="365760"/>
           </a:xfrm>
           <a:prstGeom prst="rect">
             <a:avLst/>
@@ -12388,842 +13660,6 @@
                 </a:solidFill>
                 <a:latin typeface="Calibri"/>
               </a:rPr>
-              <a:t>AIRE SUR LA LYS (1.52 km)</a:t>
-            </a:r>
-          </a:p>
-          <a:p>
-            <a:pPr algn="l"/>
-            <a:r>
-              <a:rPr sz="1000" b="0">
-                <a:solidFill>
-                  <a:srgbClr val="2CA02C"/>
-                </a:solidFill>
-                <a:latin typeface="Calibri"/>
-              </a:rPr>
-              <a:t>AIRE SUR LA LYS (2.02 km)</a:t>
-            </a:r>
-          </a:p>
-        </p:txBody>
-      </p:sp>
-      <p:sp>
-        <p:nvSpPr>
-          <p:cNvPr id="31" name="TextBox 30"/>
-          <p:cNvSpPr txBox="1"/>
-          <p:nvPr/>
-        </p:nvSpPr>
-        <p:spPr>
-          <a:xfrm>
-            <a:off x="7955279" y="3145536"/>
-            <a:ext cx="3291840" cy="566928"/>
-          </a:xfrm>
-          <a:prstGeom prst="rect">
-            <a:avLst/>
-          </a:prstGeom>
-          <a:noFill/>
-        </p:spPr>
-        <p:txBody>
-          <a:bodyPr wrap="square" lIns="45720" rIns="45720" anchor="t">
-            <a:spAutoFit/>
-          </a:bodyPr>
-          <a:lstStyle/>
-          <a:p>
-            <a:pPr algn="l"/>
-            <a:r>
-              <a:rPr sz="1000" b="0">
-                <a:solidFill>
-                  <a:srgbClr val="B0B0B8"/>
-                </a:solidFill>
-                <a:latin typeface="Calibri"/>
-              </a:rPr>
-              <a:t>—</a:t>
-            </a:r>
-          </a:p>
-        </p:txBody>
-      </p:sp>
-      <p:sp>
-        <p:nvSpPr>
-          <p:cNvPr id="32" name="Rectangle 31"/>
-          <p:cNvSpPr/>
-          <p:nvPr/>
-        </p:nvSpPr>
-        <p:spPr>
-          <a:xfrm>
-            <a:off x="457200" y="3666744"/>
-            <a:ext cx="11277295" cy="365760"/>
-          </a:xfrm>
-          <a:prstGeom prst="rect">
-            <a:avLst/>
-          </a:prstGeom>
-          <a:solidFill>
-            <a:srgbClr val="F4F4F6"/>
-          </a:solidFill>
-          <a:ln>
-            <a:noFill/>
-          </a:ln>
-          <a:effectLst/>
-        </p:spPr>
-        <p:style>
-          <a:lnRef idx="1">
-            <a:schemeClr val="accent1"/>
-          </a:lnRef>
-          <a:fillRef idx="3">
-            <a:schemeClr val="accent1"/>
-          </a:fillRef>
-          <a:effectRef idx="2">
-            <a:schemeClr val="accent1"/>
-          </a:effectRef>
-          <a:fontRef idx="minor">
-            <a:schemeClr val="lt1"/>
-          </a:fontRef>
-        </p:style>
-        <p:txBody>
-          <a:bodyPr rtlCol="0" anchor="ctr"/>
-          <a:lstStyle/>
-          <a:p>
-            <a:pPr algn="ctr"/>
-          </a:p>
-        </p:txBody>
-      </p:sp>
-      <p:sp>
-        <p:nvSpPr>
-          <p:cNvPr id="33" name="Rectangle 32"/>
-          <p:cNvSpPr/>
-          <p:nvPr/>
-        </p:nvSpPr>
-        <p:spPr>
-          <a:xfrm>
-            <a:off x="457200" y="3666744"/>
-            <a:ext cx="73152" cy="365760"/>
-          </a:xfrm>
-          <a:prstGeom prst="rect">
-            <a:avLst/>
-          </a:prstGeom>
-          <a:solidFill>
-            <a:srgbClr val="2CA02C"/>
-          </a:solidFill>
-          <a:ln>
-            <a:noFill/>
-          </a:ln>
-          <a:effectLst/>
-        </p:spPr>
-        <p:style>
-          <a:lnRef idx="1">
-            <a:schemeClr val="accent1"/>
-          </a:lnRef>
-          <a:fillRef idx="3">
-            <a:schemeClr val="accent1"/>
-          </a:fillRef>
-          <a:effectRef idx="2">
-            <a:schemeClr val="accent1"/>
-          </a:effectRef>
-          <a:fontRef idx="minor">
-            <a:schemeClr val="lt1"/>
-          </a:fontRef>
-        </p:style>
-        <p:txBody>
-          <a:bodyPr rtlCol="0" anchor="ctr"/>
-          <a:lstStyle/>
-          <a:p>
-            <a:pPr algn="ctr"/>
-          </a:p>
-        </p:txBody>
-      </p:sp>
-      <p:sp>
-        <p:nvSpPr>
-          <p:cNvPr id="34" name="TextBox 33"/>
-          <p:cNvSpPr txBox="1"/>
-          <p:nvPr/>
-        </p:nvSpPr>
-        <p:spPr>
-          <a:xfrm>
-            <a:off x="548640" y="3712464"/>
-            <a:ext cx="2651760" cy="365760"/>
-          </a:xfrm>
-          <a:prstGeom prst="rect">
-            <a:avLst/>
-          </a:prstGeom>
-          <a:noFill/>
-        </p:spPr>
-        <p:txBody>
-          <a:bodyPr wrap="square" lIns="45720" rIns="45720" anchor="t">
-            <a:spAutoFit/>
-          </a:bodyPr>
-          <a:lstStyle/>
-          <a:p>
-            <a:pPr algn="l"/>
-            <a:r>
-              <a:rPr sz="1200" b="1">
-                <a:solidFill>
-                  <a:srgbClr val="1A1A2E"/>
-                </a:solidFill>
-                <a:latin typeface="Calibri"/>
-              </a:rPr>
-              <a:t>BOLLEZEELE</a:t>
-            </a:r>
-          </a:p>
-        </p:txBody>
-      </p:sp>
-      <p:sp>
-        <p:nvSpPr>
-          <p:cNvPr id="35" name="TextBox 34"/>
-          <p:cNvSpPr txBox="1"/>
-          <p:nvPr/>
-        </p:nvSpPr>
-        <p:spPr>
-          <a:xfrm>
-            <a:off x="3200400" y="3712464"/>
-            <a:ext cx="1371600" cy="365760"/>
-          </a:xfrm>
-          <a:prstGeom prst="rect">
-            <a:avLst/>
-          </a:prstGeom>
-          <a:noFill/>
-        </p:spPr>
-        <p:txBody>
-          <a:bodyPr wrap="square" lIns="45720" rIns="45720" anchor="t">
-            <a:spAutoFit/>
-          </a:bodyPr>
-          <a:lstStyle/>
-          <a:p>
-            <a:pPr algn="l"/>
-            <a:r>
-              <a:rPr sz="1200" b="0">
-                <a:solidFill>
-                  <a:srgbClr val="1A1A2E"/>
-                </a:solidFill>
-                <a:latin typeface="Calibri"/>
-              </a:rPr>
-              <a:t>4 437 t</a:t>
-            </a:r>
-          </a:p>
-        </p:txBody>
-      </p:sp>
-      <p:sp>
-        <p:nvSpPr>
-          <p:cNvPr id="36" name="TextBox 35"/>
-          <p:cNvSpPr txBox="1"/>
-          <p:nvPr/>
-        </p:nvSpPr>
-        <p:spPr>
-          <a:xfrm>
-            <a:off x="4572000" y="3712464"/>
-            <a:ext cx="3383280" cy="365760"/>
-          </a:xfrm>
-          <a:prstGeom prst="rect">
-            <a:avLst/>
-          </a:prstGeom>
-          <a:noFill/>
-        </p:spPr>
-        <p:txBody>
-          <a:bodyPr wrap="square" lIns="45720" rIns="45720" anchor="t">
-            <a:spAutoFit/>
-          </a:bodyPr>
-          <a:lstStyle/>
-          <a:p>
-            <a:pPr algn="l"/>
-            <a:r>
-              <a:rPr sz="1000" b="0">
-                <a:solidFill>
-                  <a:srgbClr val="2CA02C"/>
-                </a:solidFill>
-                <a:latin typeface="Calibri"/>
-              </a:rPr>
-              <a:t>LEDERZEELE (6.14 km)</a:t>
-            </a:r>
-          </a:p>
-        </p:txBody>
-      </p:sp>
-      <p:sp>
-        <p:nvSpPr>
-          <p:cNvPr id="37" name="TextBox 36"/>
-          <p:cNvSpPr txBox="1"/>
-          <p:nvPr/>
-        </p:nvSpPr>
-        <p:spPr>
-          <a:xfrm>
-            <a:off x="7955279" y="3712464"/>
-            <a:ext cx="3291840" cy="365760"/>
-          </a:xfrm>
-          <a:prstGeom prst="rect">
-            <a:avLst/>
-          </a:prstGeom>
-          <a:noFill/>
-        </p:spPr>
-        <p:txBody>
-          <a:bodyPr wrap="square" lIns="45720" rIns="45720" anchor="t">
-            <a:spAutoFit/>
-          </a:bodyPr>
-          <a:lstStyle/>
-          <a:p>
-            <a:pPr algn="l"/>
-            <a:r>
-              <a:rPr sz="1000" b="0">
-                <a:solidFill>
-                  <a:srgbClr val="B0B0B8"/>
-                </a:solidFill>
-                <a:latin typeface="Calibri"/>
-              </a:rPr>
-              <a:t>—</a:t>
-            </a:r>
-          </a:p>
-        </p:txBody>
-      </p:sp>
-      <p:sp>
-        <p:nvSpPr>
-          <p:cNvPr id="38" name="Rectangle 37"/>
-          <p:cNvSpPr/>
-          <p:nvPr/>
-        </p:nvSpPr>
-        <p:spPr>
-          <a:xfrm>
-            <a:off x="457200" y="4032504"/>
-            <a:ext cx="73152" cy="365760"/>
-          </a:xfrm>
-          <a:prstGeom prst="rect">
-            <a:avLst/>
-          </a:prstGeom>
-          <a:solidFill>
-            <a:srgbClr val="9C27B0"/>
-          </a:solidFill>
-          <a:ln>
-            <a:noFill/>
-          </a:ln>
-          <a:effectLst/>
-        </p:spPr>
-        <p:style>
-          <a:lnRef idx="1">
-            <a:schemeClr val="accent1"/>
-          </a:lnRef>
-          <a:fillRef idx="3">
-            <a:schemeClr val="accent1"/>
-          </a:fillRef>
-          <a:effectRef idx="2">
-            <a:schemeClr val="accent1"/>
-          </a:effectRef>
-          <a:fontRef idx="minor">
-            <a:schemeClr val="lt1"/>
-          </a:fontRef>
-        </p:style>
-        <p:txBody>
-          <a:bodyPr rtlCol="0" anchor="ctr"/>
-          <a:lstStyle/>
-          <a:p>
-            <a:pPr algn="ctr"/>
-          </a:p>
-        </p:txBody>
-      </p:sp>
-      <p:sp>
-        <p:nvSpPr>
-          <p:cNvPr id="39" name="TextBox 38"/>
-          <p:cNvSpPr txBox="1"/>
-          <p:nvPr/>
-        </p:nvSpPr>
-        <p:spPr>
-          <a:xfrm>
-            <a:off x="548640" y="4078224"/>
-            <a:ext cx="2651760" cy="365760"/>
-          </a:xfrm>
-          <a:prstGeom prst="rect">
-            <a:avLst/>
-          </a:prstGeom>
-          <a:noFill/>
-        </p:spPr>
-        <p:txBody>
-          <a:bodyPr wrap="square" lIns="45720" rIns="45720" anchor="t">
-            <a:spAutoFit/>
-          </a:bodyPr>
-          <a:lstStyle/>
-          <a:p>
-            <a:pPr algn="l"/>
-            <a:r>
-              <a:rPr sz="1200" b="1">
-                <a:solidFill>
-                  <a:srgbClr val="1A1A2E"/>
-                </a:solidFill>
-                <a:latin typeface="Calibri"/>
-              </a:rPr>
-              <a:t>LOOBERGHE</a:t>
-            </a:r>
-          </a:p>
-        </p:txBody>
-      </p:sp>
-      <p:sp>
-        <p:nvSpPr>
-          <p:cNvPr id="40" name="TextBox 39"/>
-          <p:cNvSpPr txBox="1"/>
-          <p:nvPr/>
-        </p:nvSpPr>
-        <p:spPr>
-          <a:xfrm>
-            <a:off x="3200400" y="4078224"/>
-            <a:ext cx="1371600" cy="365760"/>
-          </a:xfrm>
-          <a:prstGeom prst="rect">
-            <a:avLst/>
-          </a:prstGeom>
-          <a:noFill/>
-        </p:spPr>
-        <p:txBody>
-          <a:bodyPr wrap="square" lIns="45720" rIns="45720" anchor="t">
-            <a:spAutoFit/>
-          </a:bodyPr>
-          <a:lstStyle/>
-          <a:p>
-            <a:pPr algn="l"/>
-            <a:r>
-              <a:rPr sz="1200" b="0">
-                <a:solidFill>
-                  <a:srgbClr val="1A1A2E"/>
-                </a:solidFill>
-                <a:latin typeface="Calibri"/>
-              </a:rPr>
-              <a:t>3 914 t</a:t>
-            </a:r>
-          </a:p>
-        </p:txBody>
-      </p:sp>
-      <p:sp>
-        <p:nvSpPr>
-          <p:cNvPr id="41" name="TextBox 40"/>
-          <p:cNvSpPr txBox="1"/>
-          <p:nvPr/>
-        </p:nvSpPr>
-        <p:spPr>
-          <a:xfrm>
-            <a:off x="4572000" y="4078224"/>
-            <a:ext cx="3383280" cy="365760"/>
-          </a:xfrm>
-          <a:prstGeom prst="rect">
-            <a:avLst/>
-          </a:prstGeom>
-          <a:noFill/>
-        </p:spPr>
-        <p:txBody>
-          <a:bodyPr wrap="square" lIns="45720" rIns="45720" anchor="t">
-            <a:spAutoFit/>
-          </a:bodyPr>
-          <a:lstStyle/>
-          <a:p>
-            <a:pPr algn="l"/>
-            <a:r>
-              <a:rPr sz="1000" b="0">
-                <a:solidFill>
-                  <a:srgbClr val="2CA02C"/>
-                </a:solidFill>
-                <a:latin typeface="Calibri"/>
-              </a:rPr>
-              <a:t>DUNKERQUE (6.74 km)</a:t>
-            </a:r>
-          </a:p>
-        </p:txBody>
-      </p:sp>
-      <p:sp>
-        <p:nvSpPr>
-          <p:cNvPr id="42" name="TextBox 41"/>
-          <p:cNvSpPr txBox="1"/>
-          <p:nvPr/>
-        </p:nvSpPr>
-        <p:spPr>
-          <a:xfrm>
-            <a:off x="7955279" y="4078224"/>
-            <a:ext cx="3291840" cy="365760"/>
-          </a:xfrm>
-          <a:prstGeom prst="rect">
-            <a:avLst/>
-          </a:prstGeom>
-          <a:noFill/>
-        </p:spPr>
-        <p:txBody>
-          <a:bodyPr wrap="square" lIns="45720" rIns="45720" anchor="t">
-            <a:spAutoFit/>
-          </a:bodyPr>
-          <a:lstStyle/>
-          <a:p>
-            <a:pPr algn="l"/>
-            <a:r>
-              <a:rPr sz="1000" b="0">
-                <a:solidFill>
-                  <a:srgbClr val="1F77B4"/>
-                </a:solidFill>
-                <a:latin typeface="Calibri"/>
-              </a:rPr>
-              <a:t>BIERNE (0.92 km)</a:t>
-            </a:r>
-          </a:p>
-        </p:txBody>
-      </p:sp>
-      <p:sp>
-        <p:nvSpPr>
-          <p:cNvPr id="43" name="Rectangle 42"/>
-          <p:cNvSpPr/>
-          <p:nvPr/>
-        </p:nvSpPr>
-        <p:spPr>
-          <a:xfrm>
-            <a:off x="457200" y="4398264"/>
-            <a:ext cx="11277295" cy="365760"/>
-          </a:xfrm>
-          <a:prstGeom prst="rect">
-            <a:avLst/>
-          </a:prstGeom>
-          <a:solidFill>
-            <a:srgbClr val="F4F4F6"/>
-          </a:solidFill>
-          <a:ln>
-            <a:noFill/>
-          </a:ln>
-          <a:effectLst/>
-        </p:spPr>
-        <p:style>
-          <a:lnRef idx="1">
-            <a:schemeClr val="accent1"/>
-          </a:lnRef>
-          <a:fillRef idx="3">
-            <a:schemeClr val="accent1"/>
-          </a:fillRef>
-          <a:effectRef idx="2">
-            <a:schemeClr val="accent1"/>
-          </a:effectRef>
-          <a:fontRef idx="minor">
-            <a:schemeClr val="lt1"/>
-          </a:fontRef>
-        </p:style>
-        <p:txBody>
-          <a:bodyPr rtlCol="0" anchor="ctr"/>
-          <a:lstStyle/>
-          <a:p>
-            <a:pPr algn="ctr"/>
-          </a:p>
-        </p:txBody>
-      </p:sp>
-      <p:sp>
-        <p:nvSpPr>
-          <p:cNvPr id="44" name="Rectangle 43"/>
-          <p:cNvSpPr/>
-          <p:nvPr/>
-        </p:nvSpPr>
-        <p:spPr>
-          <a:xfrm>
-            <a:off x="457200" y="4398264"/>
-            <a:ext cx="73152" cy="365760"/>
-          </a:xfrm>
-          <a:prstGeom prst="rect">
-            <a:avLst/>
-          </a:prstGeom>
-          <a:solidFill>
-            <a:srgbClr val="1F77B4"/>
-          </a:solidFill>
-          <a:ln>
-            <a:noFill/>
-          </a:ln>
-          <a:effectLst/>
-        </p:spPr>
-        <p:style>
-          <a:lnRef idx="1">
-            <a:schemeClr val="accent1"/>
-          </a:lnRef>
-          <a:fillRef idx="3">
-            <a:schemeClr val="accent1"/>
-          </a:fillRef>
-          <a:effectRef idx="2">
-            <a:schemeClr val="accent1"/>
-          </a:effectRef>
-          <a:fontRef idx="minor">
-            <a:schemeClr val="lt1"/>
-          </a:fontRef>
-        </p:style>
-        <p:txBody>
-          <a:bodyPr rtlCol="0" anchor="ctr"/>
-          <a:lstStyle/>
-          <a:p>
-            <a:pPr algn="ctr"/>
-          </a:p>
-        </p:txBody>
-      </p:sp>
-      <p:sp>
-        <p:nvSpPr>
-          <p:cNvPr id="45" name="TextBox 44"/>
-          <p:cNvSpPr txBox="1"/>
-          <p:nvPr/>
-        </p:nvSpPr>
-        <p:spPr>
-          <a:xfrm>
-            <a:off x="548640" y="4443984"/>
-            <a:ext cx="2651760" cy="365760"/>
-          </a:xfrm>
-          <a:prstGeom prst="rect">
-            <a:avLst/>
-          </a:prstGeom>
-          <a:noFill/>
-        </p:spPr>
-        <p:txBody>
-          <a:bodyPr wrap="square" lIns="45720" rIns="45720" anchor="t">
-            <a:spAutoFit/>
-          </a:bodyPr>
-          <a:lstStyle/>
-          <a:p>
-            <a:pPr algn="l"/>
-            <a:r>
-              <a:rPr sz="1200" b="1">
-                <a:solidFill>
-                  <a:srgbClr val="1A1A2E"/>
-                </a:solidFill>
-                <a:latin typeface="Calibri"/>
-              </a:rPr>
-              <a:t>OYE PLAGE</a:t>
-            </a:r>
-          </a:p>
-        </p:txBody>
-      </p:sp>
-      <p:sp>
-        <p:nvSpPr>
-          <p:cNvPr id="46" name="TextBox 45"/>
-          <p:cNvSpPr txBox="1"/>
-          <p:nvPr/>
-        </p:nvSpPr>
-        <p:spPr>
-          <a:xfrm>
-            <a:off x="3200400" y="4443984"/>
-            <a:ext cx="1371600" cy="365760"/>
-          </a:xfrm>
-          <a:prstGeom prst="rect">
-            <a:avLst/>
-          </a:prstGeom>
-          <a:noFill/>
-        </p:spPr>
-        <p:txBody>
-          <a:bodyPr wrap="square" lIns="45720" rIns="45720" anchor="t">
-            <a:spAutoFit/>
-          </a:bodyPr>
-          <a:lstStyle/>
-          <a:p>
-            <a:pPr algn="l"/>
-            <a:r>
-              <a:rPr sz="1200" b="0">
-                <a:solidFill>
-                  <a:srgbClr val="1A1A2E"/>
-                </a:solidFill>
-                <a:latin typeface="Calibri"/>
-              </a:rPr>
-              <a:t>3 670 t</a:t>
-            </a:r>
-          </a:p>
-        </p:txBody>
-      </p:sp>
-      <p:sp>
-        <p:nvSpPr>
-          <p:cNvPr id="47" name="TextBox 46"/>
-          <p:cNvSpPr txBox="1"/>
-          <p:nvPr/>
-        </p:nvSpPr>
-        <p:spPr>
-          <a:xfrm>
-            <a:off x="4572000" y="4443984"/>
-            <a:ext cx="3383280" cy="365760"/>
-          </a:xfrm>
-          <a:prstGeom prst="rect">
-            <a:avLst/>
-          </a:prstGeom>
-          <a:noFill/>
-        </p:spPr>
-        <p:txBody>
-          <a:bodyPr wrap="square" lIns="45720" rIns="45720" anchor="t">
-            <a:spAutoFit/>
-          </a:bodyPr>
-          <a:lstStyle/>
-          <a:p>
-            <a:pPr algn="l"/>
-            <a:r>
-              <a:rPr sz="1000" b="0">
-                <a:solidFill>
-                  <a:srgbClr val="B0B0B8"/>
-                </a:solidFill>
-                <a:latin typeface="Calibri"/>
-              </a:rPr>
-              <a:t>—</a:t>
-            </a:r>
-          </a:p>
-        </p:txBody>
-      </p:sp>
-      <p:sp>
-        <p:nvSpPr>
-          <p:cNvPr id="48" name="TextBox 47"/>
-          <p:cNvSpPr txBox="1"/>
-          <p:nvPr/>
-        </p:nvSpPr>
-        <p:spPr>
-          <a:xfrm>
-            <a:off x="7955279" y="4443984"/>
-            <a:ext cx="3291840" cy="365760"/>
-          </a:xfrm>
-          <a:prstGeom prst="rect">
-            <a:avLst/>
-          </a:prstGeom>
-          <a:noFill/>
-        </p:spPr>
-        <p:txBody>
-          <a:bodyPr wrap="square" lIns="45720" rIns="45720" anchor="t">
-            <a:spAutoFit/>
-          </a:bodyPr>
-          <a:lstStyle/>
-          <a:p>
-            <a:pPr algn="l"/>
-            <a:r>
-              <a:rPr sz="1000" b="0">
-                <a:solidFill>
-                  <a:srgbClr val="1F77B4"/>
-                </a:solidFill>
-                <a:latin typeface="Calibri"/>
-              </a:rPr>
-              <a:t>VIEILLE-EGLISE (6.57 km)</a:t>
-            </a:r>
-          </a:p>
-        </p:txBody>
-      </p:sp>
-      <p:sp>
-        <p:nvSpPr>
-          <p:cNvPr id="49" name="Rectangle 48"/>
-          <p:cNvSpPr/>
-          <p:nvPr/>
-        </p:nvSpPr>
-        <p:spPr>
-          <a:xfrm>
-            <a:off x="457200" y="4764024"/>
-            <a:ext cx="73152" cy="365760"/>
-          </a:xfrm>
-          <a:prstGeom prst="rect">
-            <a:avLst/>
-          </a:prstGeom>
-          <a:solidFill>
-            <a:srgbClr val="2CA02C"/>
-          </a:solidFill>
-          <a:ln>
-            <a:noFill/>
-          </a:ln>
-          <a:effectLst/>
-        </p:spPr>
-        <p:style>
-          <a:lnRef idx="1">
-            <a:schemeClr val="accent1"/>
-          </a:lnRef>
-          <a:fillRef idx="3">
-            <a:schemeClr val="accent1"/>
-          </a:fillRef>
-          <a:effectRef idx="2">
-            <a:schemeClr val="accent1"/>
-          </a:effectRef>
-          <a:fontRef idx="minor">
-            <a:schemeClr val="lt1"/>
-          </a:fontRef>
-        </p:style>
-        <p:txBody>
-          <a:bodyPr rtlCol="0" anchor="ctr"/>
-          <a:lstStyle/>
-          <a:p>
-            <a:pPr algn="ctr"/>
-          </a:p>
-        </p:txBody>
-      </p:sp>
-      <p:sp>
-        <p:nvSpPr>
-          <p:cNvPr id="50" name="TextBox 49"/>
-          <p:cNvSpPr txBox="1"/>
-          <p:nvPr/>
-        </p:nvSpPr>
-        <p:spPr>
-          <a:xfrm>
-            <a:off x="548640" y="4809744"/>
-            <a:ext cx="2651760" cy="365760"/>
-          </a:xfrm>
-          <a:prstGeom prst="rect">
-            <a:avLst/>
-          </a:prstGeom>
-          <a:noFill/>
-        </p:spPr>
-        <p:txBody>
-          <a:bodyPr wrap="square" lIns="45720" rIns="45720" anchor="t">
-            <a:spAutoFit/>
-          </a:bodyPr>
-          <a:lstStyle/>
-          <a:p>
-            <a:pPr algn="l"/>
-            <a:r>
-              <a:rPr sz="1200" b="1">
-                <a:solidFill>
-                  <a:srgbClr val="1A1A2E"/>
-                </a:solidFill>
-                <a:latin typeface="Calibri"/>
-              </a:rPr>
-              <a:t>LEDERZEELE</a:t>
-            </a:r>
-          </a:p>
-        </p:txBody>
-      </p:sp>
-      <p:sp>
-        <p:nvSpPr>
-          <p:cNvPr id="51" name="TextBox 50"/>
-          <p:cNvSpPr txBox="1"/>
-          <p:nvPr/>
-        </p:nvSpPr>
-        <p:spPr>
-          <a:xfrm>
-            <a:off x="3200400" y="4809744"/>
-            <a:ext cx="1371600" cy="365760"/>
-          </a:xfrm>
-          <a:prstGeom prst="rect">
-            <a:avLst/>
-          </a:prstGeom>
-          <a:noFill/>
-        </p:spPr>
-        <p:txBody>
-          <a:bodyPr wrap="square" lIns="45720" rIns="45720" anchor="t">
-            <a:spAutoFit/>
-          </a:bodyPr>
-          <a:lstStyle/>
-          <a:p>
-            <a:pPr algn="l"/>
-            <a:r>
-              <a:rPr sz="1200" b="0">
-                <a:solidFill>
-                  <a:srgbClr val="1A1A2E"/>
-                </a:solidFill>
-                <a:latin typeface="Calibri"/>
-              </a:rPr>
-              <a:t>3 156 t</a:t>
-            </a:r>
-          </a:p>
-        </p:txBody>
-      </p:sp>
-      <p:sp>
-        <p:nvSpPr>
-          <p:cNvPr id="52" name="TextBox 51"/>
-          <p:cNvSpPr txBox="1"/>
-          <p:nvPr/>
-        </p:nvSpPr>
-        <p:spPr>
-          <a:xfrm>
-            <a:off x="4572000" y="4809744"/>
-            <a:ext cx="3383280" cy="365760"/>
-          </a:xfrm>
-          <a:prstGeom prst="rect">
-            <a:avLst/>
-          </a:prstGeom>
-          <a:noFill/>
-        </p:spPr>
-        <p:txBody>
-          <a:bodyPr wrap="square" lIns="45720" rIns="45720" anchor="t">
-            <a:spAutoFit/>
-          </a:bodyPr>
-          <a:lstStyle/>
-          <a:p>
-            <a:pPr algn="l"/>
-            <a:r>
-              <a:rPr sz="1000" b="0">
-                <a:solidFill>
-                  <a:srgbClr val="2CA02C"/>
-                </a:solidFill>
-                <a:latin typeface="Calibri"/>
-              </a:rPr>
               <a:t>LEDERZEELE (0.98 km)</a:t>
             </a:r>
           </a:p>
@@ -13231,425 +13667,13 @@
       </p:sp>
       <p:sp>
         <p:nvSpPr>
-          <p:cNvPr id="53" name="TextBox 52"/>
-          <p:cNvSpPr txBox="1"/>
-          <p:nvPr/>
-        </p:nvSpPr>
-        <p:spPr>
-          <a:xfrm>
-            <a:off x="7955279" y="4809744"/>
-            <a:ext cx="3291840" cy="365760"/>
-          </a:xfrm>
-          <a:prstGeom prst="rect">
-            <a:avLst/>
-          </a:prstGeom>
-          <a:noFill/>
-        </p:spPr>
-        <p:txBody>
-          <a:bodyPr wrap="square" lIns="45720" rIns="45720" anchor="t">
-            <a:spAutoFit/>
-          </a:bodyPr>
-          <a:lstStyle/>
-          <a:p>
-            <a:pPr algn="l"/>
-            <a:r>
-              <a:rPr sz="1000" b="0">
-                <a:solidFill>
-                  <a:srgbClr val="B0B0B8"/>
-                </a:solidFill>
-                <a:latin typeface="Calibri"/>
-              </a:rPr>
-              <a:t>—</a:t>
-            </a:r>
-          </a:p>
-        </p:txBody>
-      </p:sp>
-      <p:sp>
-        <p:nvSpPr>
-          <p:cNvPr id="54" name="Rectangle 53"/>
-          <p:cNvSpPr/>
-          <p:nvPr/>
-        </p:nvSpPr>
-        <p:spPr>
-          <a:xfrm>
-            <a:off x="457200" y="5129784"/>
-            <a:ext cx="11277295" cy="365760"/>
-          </a:xfrm>
-          <a:prstGeom prst="rect">
-            <a:avLst/>
-          </a:prstGeom>
-          <a:solidFill>
-            <a:srgbClr val="F4F4F6"/>
-          </a:solidFill>
-          <a:ln>
-            <a:noFill/>
-          </a:ln>
-          <a:effectLst/>
-        </p:spPr>
-        <p:style>
-          <a:lnRef idx="1">
-            <a:schemeClr val="accent1"/>
-          </a:lnRef>
-          <a:fillRef idx="3">
-            <a:schemeClr val="accent1"/>
-          </a:fillRef>
-          <a:effectRef idx="2">
-            <a:schemeClr val="accent1"/>
-          </a:effectRef>
-          <a:fontRef idx="minor">
-            <a:schemeClr val="lt1"/>
-          </a:fontRef>
-        </p:style>
-        <p:txBody>
-          <a:bodyPr rtlCol="0" anchor="ctr"/>
-          <a:lstStyle/>
-          <a:p>
-            <a:pPr algn="ctr"/>
-          </a:p>
-        </p:txBody>
-      </p:sp>
-      <p:sp>
-        <p:nvSpPr>
-          <p:cNvPr id="55" name="Rectangle 54"/>
-          <p:cNvSpPr/>
-          <p:nvPr/>
-        </p:nvSpPr>
-        <p:spPr>
-          <a:xfrm>
-            <a:off x="457200" y="5129784"/>
-            <a:ext cx="73152" cy="365760"/>
-          </a:xfrm>
-          <a:prstGeom prst="rect">
-            <a:avLst/>
-          </a:prstGeom>
-          <a:solidFill>
-            <a:srgbClr val="2CA02C"/>
-          </a:solidFill>
-          <a:ln>
-            <a:noFill/>
-          </a:ln>
-          <a:effectLst/>
-        </p:spPr>
-        <p:style>
-          <a:lnRef idx="1">
-            <a:schemeClr val="accent1"/>
-          </a:lnRef>
-          <a:fillRef idx="3">
-            <a:schemeClr val="accent1"/>
-          </a:fillRef>
-          <a:effectRef idx="2">
-            <a:schemeClr val="accent1"/>
-          </a:effectRef>
-          <a:fontRef idx="minor">
-            <a:schemeClr val="lt1"/>
-          </a:fontRef>
-        </p:style>
-        <p:txBody>
-          <a:bodyPr rtlCol="0" anchor="ctr"/>
-          <a:lstStyle/>
-          <a:p>
-            <a:pPr algn="ctr"/>
-          </a:p>
-        </p:txBody>
-      </p:sp>
-      <p:sp>
-        <p:nvSpPr>
-          <p:cNvPr id="56" name="TextBox 55"/>
-          <p:cNvSpPr txBox="1"/>
-          <p:nvPr/>
-        </p:nvSpPr>
-        <p:spPr>
-          <a:xfrm>
-            <a:off x="548640" y="5175504"/>
-            <a:ext cx="2651760" cy="365760"/>
-          </a:xfrm>
-          <a:prstGeom prst="rect">
-            <a:avLst/>
-          </a:prstGeom>
-          <a:noFill/>
-        </p:spPr>
-        <p:txBody>
-          <a:bodyPr wrap="square" lIns="45720" rIns="45720" anchor="t">
-            <a:spAutoFit/>
-          </a:bodyPr>
-          <a:lstStyle/>
-          <a:p>
-            <a:pPr algn="l"/>
-            <a:r>
-              <a:rPr sz="1200" b="1">
-                <a:solidFill>
-                  <a:srgbClr val="1A1A2E"/>
-                </a:solidFill>
-                <a:latin typeface="Calibri"/>
-              </a:rPr>
-              <a:t>LEULINGHEM</a:t>
-            </a:r>
-          </a:p>
-        </p:txBody>
-      </p:sp>
-      <p:sp>
-        <p:nvSpPr>
-          <p:cNvPr id="57" name="TextBox 56"/>
-          <p:cNvSpPr txBox="1"/>
-          <p:nvPr/>
-        </p:nvSpPr>
-        <p:spPr>
-          <a:xfrm>
-            <a:off x="3200400" y="5175504"/>
-            <a:ext cx="1371600" cy="365760"/>
-          </a:xfrm>
-          <a:prstGeom prst="rect">
-            <a:avLst/>
-          </a:prstGeom>
-          <a:noFill/>
-        </p:spPr>
-        <p:txBody>
-          <a:bodyPr wrap="square" lIns="45720" rIns="45720" anchor="t">
-            <a:spAutoFit/>
-          </a:bodyPr>
-          <a:lstStyle/>
-          <a:p>
-            <a:pPr algn="l"/>
-            <a:r>
-              <a:rPr sz="1200" b="0">
-                <a:solidFill>
-                  <a:srgbClr val="1A1A2E"/>
-                </a:solidFill>
-                <a:latin typeface="Calibri"/>
-              </a:rPr>
-              <a:t>2 237 t</a:t>
-            </a:r>
-          </a:p>
-        </p:txBody>
-      </p:sp>
-      <p:sp>
-        <p:nvSpPr>
-          <p:cNvPr id="58" name="TextBox 57"/>
-          <p:cNvSpPr txBox="1"/>
-          <p:nvPr/>
-        </p:nvSpPr>
-        <p:spPr>
-          <a:xfrm>
-            <a:off x="4572000" y="5175504"/>
-            <a:ext cx="3383280" cy="365760"/>
-          </a:xfrm>
-          <a:prstGeom prst="rect">
-            <a:avLst/>
-          </a:prstGeom>
-          <a:noFill/>
-        </p:spPr>
-        <p:txBody>
-          <a:bodyPr wrap="square" lIns="45720" rIns="45720" anchor="t">
-            <a:spAutoFit/>
-          </a:bodyPr>
-          <a:lstStyle/>
-          <a:p>
-            <a:pPr algn="l"/>
-            <a:r>
-              <a:rPr sz="1000" b="0">
-                <a:solidFill>
-                  <a:srgbClr val="2CA02C"/>
-                </a:solidFill>
-                <a:latin typeface="Calibri"/>
-              </a:rPr>
-              <a:t>ZUDAUSQUES (2.08 km)</a:t>
-            </a:r>
-          </a:p>
-        </p:txBody>
-      </p:sp>
-      <p:sp>
-        <p:nvSpPr>
-          <p:cNvPr id="59" name="TextBox 58"/>
-          <p:cNvSpPr txBox="1"/>
-          <p:nvPr/>
-        </p:nvSpPr>
-        <p:spPr>
-          <a:xfrm>
-            <a:off x="7955279" y="5175504"/>
-            <a:ext cx="3291840" cy="365760"/>
-          </a:xfrm>
-          <a:prstGeom prst="rect">
-            <a:avLst/>
-          </a:prstGeom>
-          <a:noFill/>
-        </p:spPr>
-        <p:txBody>
-          <a:bodyPr wrap="square" lIns="45720" rIns="45720" anchor="t">
-            <a:spAutoFit/>
-          </a:bodyPr>
-          <a:lstStyle/>
-          <a:p>
-            <a:pPr algn="l"/>
-            <a:r>
-              <a:rPr sz="1000" b="0">
-                <a:solidFill>
-                  <a:srgbClr val="B0B0B8"/>
-                </a:solidFill>
-                <a:latin typeface="Calibri"/>
-              </a:rPr>
-              <a:t>—</a:t>
-            </a:r>
-          </a:p>
-        </p:txBody>
-      </p:sp>
-      <p:sp>
-        <p:nvSpPr>
-          <p:cNvPr id="60" name="Rectangle 59"/>
-          <p:cNvSpPr/>
-          <p:nvPr/>
-        </p:nvSpPr>
-        <p:spPr>
-          <a:xfrm>
-            <a:off x="457200" y="5495544"/>
-            <a:ext cx="73152" cy="365760"/>
-          </a:xfrm>
-          <a:prstGeom prst="rect">
-            <a:avLst/>
-          </a:prstGeom>
-          <a:solidFill>
-            <a:srgbClr val="2CA02C"/>
-          </a:solidFill>
-          <a:ln>
-            <a:noFill/>
-          </a:ln>
-          <a:effectLst/>
-        </p:spPr>
-        <p:style>
-          <a:lnRef idx="1">
-            <a:schemeClr val="accent1"/>
-          </a:lnRef>
-          <a:fillRef idx="3">
-            <a:schemeClr val="accent1"/>
-          </a:fillRef>
-          <a:effectRef idx="2">
-            <a:schemeClr val="accent1"/>
-          </a:effectRef>
-          <a:fontRef idx="minor">
-            <a:schemeClr val="lt1"/>
-          </a:fontRef>
-        </p:style>
-        <p:txBody>
-          <a:bodyPr rtlCol="0" anchor="ctr"/>
-          <a:lstStyle/>
-          <a:p>
-            <a:pPr algn="ctr"/>
-          </a:p>
-        </p:txBody>
-      </p:sp>
-      <p:sp>
-        <p:nvSpPr>
-          <p:cNvPr id="61" name="TextBox 60"/>
-          <p:cNvSpPr txBox="1"/>
-          <p:nvPr/>
-        </p:nvSpPr>
-        <p:spPr>
-          <a:xfrm>
-            <a:off x="548640" y="5541264"/>
-            <a:ext cx="2651760" cy="365760"/>
-          </a:xfrm>
-          <a:prstGeom prst="rect">
-            <a:avLst/>
-          </a:prstGeom>
-          <a:noFill/>
-        </p:spPr>
-        <p:txBody>
-          <a:bodyPr wrap="square" lIns="45720" rIns="45720" anchor="t">
-            <a:spAutoFit/>
-          </a:bodyPr>
-          <a:lstStyle/>
-          <a:p>
-            <a:pPr algn="l"/>
-            <a:r>
-              <a:rPr sz="1200" b="1">
-                <a:solidFill>
-                  <a:srgbClr val="1A1A2E"/>
-                </a:solidFill>
-                <a:latin typeface="Calibri"/>
-              </a:rPr>
-              <a:t>REXPOEDE</a:t>
-            </a:r>
-          </a:p>
-        </p:txBody>
-      </p:sp>
-      <p:sp>
-        <p:nvSpPr>
-          <p:cNvPr id="62" name="TextBox 61"/>
-          <p:cNvSpPr txBox="1"/>
-          <p:nvPr/>
-        </p:nvSpPr>
-        <p:spPr>
-          <a:xfrm>
-            <a:off x="3200400" y="5541264"/>
-            <a:ext cx="1371600" cy="365760"/>
-          </a:xfrm>
-          <a:prstGeom prst="rect">
-            <a:avLst/>
-          </a:prstGeom>
-          <a:noFill/>
-        </p:spPr>
-        <p:txBody>
-          <a:bodyPr wrap="square" lIns="45720" rIns="45720" anchor="t">
-            <a:spAutoFit/>
-          </a:bodyPr>
-          <a:lstStyle/>
-          <a:p>
-            <a:pPr algn="l"/>
-            <a:r>
-              <a:rPr sz="1200" b="0">
-                <a:solidFill>
-                  <a:srgbClr val="1A1A2E"/>
-                </a:solidFill>
-                <a:latin typeface="Calibri"/>
-              </a:rPr>
-              <a:t>2 193 t</a:t>
-            </a:r>
-          </a:p>
-        </p:txBody>
-      </p:sp>
-      <p:sp>
-        <p:nvSpPr>
-          <p:cNvPr id="63" name="TextBox 62"/>
-          <p:cNvSpPr txBox="1"/>
-          <p:nvPr/>
-        </p:nvSpPr>
-        <p:spPr>
-          <a:xfrm>
-            <a:off x="4572000" y="5541264"/>
-            <a:ext cx="3383280" cy="365760"/>
-          </a:xfrm>
-          <a:prstGeom prst="rect">
-            <a:avLst/>
-          </a:prstGeom>
-          <a:noFill/>
-        </p:spPr>
-        <p:txBody>
-          <a:bodyPr wrap="square" lIns="45720" rIns="45720" anchor="t">
-            <a:spAutoFit/>
-          </a:bodyPr>
-          <a:lstStyle/>
-          <a:p>
-            <a:pPr algn="l"/>
-            <a:r>
-              <a:rPr sz="1000" b="0">
-                <a:solidFill>
-                  <a:srgbClr val="2CA02C"/>
-                </a:solidFill>
-                <a:latin typeface="Calibri"/>
-              </a:rPr>
-              <a:t>HONDSCHOOTE (5.36 km)</a:t>
-            </a:r>
-          </a:p>
-        </p:txBody>
-      </p:sp>
-      <p:sp>
-        <p:nvSpPr>
           <p:cNvPr id="64" name="TextBox 63"/>
           <p:cNvSpPr txBox="1"/>
           <p:nvPr/>
         </p:nvSpPr>
         <p:spPr>
           <a:xfrm>
-            <a:off x="7955279" y="5541264"/>
+            <a:off x="7955279" y="5943600"/>
             <a:ext cx="3291840" cy="365760"/>
           </a:xfrm>
           <a:prstGeom prst="rect">
@@ -13790,7 +13814,7 @@
         <p:spPr>
           <a:xfrm>
             <a:off x="457200" y="960120"/>
-            <a:ext cx="11247120" cy="9147336"/>
+            <a:ext cx="11247120" cy="6970823"/>
           </a:xfrm>
           <a:prstGeom prst="rect">
             <a:avLst/>
@@ -13827,7 +13851,7 @@
                 </a:solidFill>
                 <a:latin typeface="Calibri"/>
               </a:rPr>
-              <a:t>23 silos Noriap actifs sur la R25 en Flandre — 69 kt collectées (R25).</a:t>
+              <a:t>27 silos Noriap actifs sur la R25 en Flandre — 93 kt collectées (R25).</a:t>
             </a:r>
           </a:p>
         </p:txBody>
@@ -13946,7 +13970,7 @@
         <p:spPr>
           <a:xfrm>
             <a:off x="457200" y="960120"/>
-            <a:ext cx="11247120" cy="9147336"/>
+            <a:ext cx="11247120" cy="6970823"/>
           </a:xfrm>
           <a:prstGeom prst="rect">
             <a:avLst/>
@@ -13983,7 +14007,7 @@
                 </a:solidFill>
                 <a:latin typeface="Calibri"/>
               </a:rPr>
-              <a:t>26 silos Unéal géolocalisés dans le périmètre Flandre.</a:t>
+              <a:t>33 silos Unéal géolocalisés dans le périmètre Flandre.</a:t>
             </a:r>
           </a:p>
         </p:txBody>
@@ -14102,7 +14126,7 @@
         <p:spPr>
           <a:xfrm>
             <a:off x="457200" y="960120"/>
-            <a:ext cx="11247120" cy="9147336"/>
+            <a:ext cx="11247120" cy="6970823"/>
           </a:xfrm>
           <a:prstGeom prst="rect">
             <a:avLst/>
@@ -14258,7 +14282,7 @@
         <p:spPr>
           <a:xfrm>
             <a:off x="457200" y="960120"/>
-            <a:ext cx="11247120" cy="9157161"/>
+            <a:ext cx="11247120" cy="6976528"/>
           </a:xfrm>
           <a:prstGeom prst="rect">
             <a:avLst/>
@@ -14295,7 +14319,7 @@
                 </a:solidFill>
                 <a:latin typeface="Calibri"/>
               </a:rPr>
-              <a:t>16 silos Noriap ont un Unéal à &lt;7 km — 46 kt R25 concernés.</a:t>
+              <a:t>18 silos Noriap ont un Unéal à &lt;7 km — 62 kt R25 concernés.</a:t>
             </a:r>
           </a:p>
         </p:txBody>
@@ -14414,7 +14438,7 @@
         <p:spPr>
           <a:xfrm>
             <a:off x="457200" y="960120"/>
-            <a:ext cx="11247120" cy="9147336"/>
+            <a:ext cx="11247120" cy="6970823"/>
           </a:xfrm>
           <a:prstGeom prst="rect">
             <a:avLst/>

</xml_diff>

<commit_message>
Recalcul complet apres fix Looberghe+Bouquemaison: Voronoi RPG +2000 ha, Flandre doublons NxT 7->6
</commit_message>
<xml_diff>
--- a/fusion_flandre_codir.pptx
+++ b/fusion_flandre_codir.pptx
@@ -6513,7 +6513,7 @@
                 </a:solidFill>
                 <a:latin typeface="Calibri"/>
               </a:rPr>
-              <a:t>3 sites</a:t>
+              <a:t>2 sites</a:t>
             </a:r>
           </a:p>
         </p:txBody>
@@ -6583,7 +6583,7 @@
                 </a:solidFill>
                 <a:latin typeface="Calibri"/>
               </a:rPr>
-              <a:t>16.6 kt</a:t>
+              <a:t>12.7 kt</a:t>
             </a:r>
           </a:p>
         </p:txBody>
@@ -6653,7 +6653,7 @@
                 </a:solidFill>
                 <a:latin typeface="Calibri"/>
               </a:rPr>
-              <a:t>13.3 kt (80.1%)</a:t>
+              <a:t>9.4 kt (73.9%)</a:t>
             </a:r>
           </a:p>
         </p:txBody>
@@ -6723,7 +6723,7 @@
                 </a:solidFill>
                 <a:latin typeface="Calibri"/>
               </a:rPr>
-              <a:t>+1 050 k€</a:t>
+              <a:t>+700 k€</a:t>
             </a:r>
           </a:p>
         </p:txBody>
@@ -6793,7 +6793,7 @@
                 </a:solidFill>
                 <a:latin typeface="Calibri"/>
               </a:rPr>
-              <a:t>-199 k€</a:t>
+              <a:t>-141 k€</a:t>
             </a:r>
           </a:p>
         </p:txBody>
@@ -6872,7 +6872,7 @@
                 </a:solidFill>
                 <a:latin typeface="Calibri"/>
               </a:rPr>
-              <a:t>NET : 0.85 M€/an</a:t>
+              <a:t>NET : 0.56 M€/an</a:t>
             </a:r>
           </a:p>
         </p:txBody>
@@ -10141,7 +10141,7 @@
                 </a:solidFill>
                 <a:latin typeface="Calibri"/>
               </a:rPr>
-              <a:t>7 doublons Noriap &lt;7 km</a:t>
+              <a:t>6 doublons Noriap &lt;7 km</a:t>
             </a:r>
           </a:p>
         </p:txBody>
@@ -10624,7 +10624,7 @@
                 </a:solidFill>
                 <a:latin typeface="Calibri"/>
               </a:rPr>
-              <a:t>18 U • 7 T • 3 multi</a:t>
+              <a:t>18 U • 6 T • 2 multi</a:t>
             </a:r>
           </a:p>
         </p:txBody>
@@ -11250,7 +11250,7 @@
                 </a:solidFill>
                 <a:latin typeface="Calibri"/>
               </a:rPr>
-              <a:t>3 sites prioritaires</a:t>
+              <a:t>2 sites prioritaires</a:t>
             </a:r>
             <a:r>
               <a:rPr sz="1300" b="0">
@@ -13119,7 +13119,7 @@
             <a:avLst/>
           </a:prstGeom>
           <a:solidFill>
-            <a:srgbClr val="9C27B0"/>
+            <a:srgbClr val="2CA02C"/>
           </a:solidFill>
           <a:ln>
             <a:noFill/>
@@ -13248,7 +13248,7 @@
                 </a:solidFill>
                 <a:latin typeface="Calibri"/>
               </a:rPr>
-              <a:t>DUNKERQUE (6.74 km)</a:t>
+              <a:t>CAPPELLE-BROUCK (4.04 km)</a:t>
             </a:r>
           </a:p>
         </p:txBody>
@@ -13279,11 +13279,11 @@
             <a:r>
               <a:rPr sz="1000" b="0">
                 <a:solidFill>
-                  <a:srgbClr val="1F77B4"/>
-                </a:solidFill>
-                <a:latin typeface="Calibri"/>
-              </a:rPr>
-              <a:t>BIERNE (0.92 km)</a:t>
+                  <a:srgbClr val="B0B0B8"/>
+                </a:solidFill>
+                <a:latin typeface="Calibri"/>
+              </a:rPr>
+              <a:t>—</a:t>
             </a:r>
           </a:p>
         </p:txBody>
@@ -14475,7 +14475,7 @@
                 </a:solidFill>
                 <a:latin typeface="Calibri"/>
               </a:rPr>
-              <a:t>7 silos Noriap ont un Ternoveo à &lt;7 km — 23 kt R25 concernés.</a:t>
+              <a:t>6 silos Noriap ont un Ternoveo à &lt;7 km — 19 kt R25 concernés.</a:t>
             </a:r>
           </a:p>
         </p:txBody>

</xml_diff>